<commit_message>
Hand-centre string experiment, README23, project report and presentation update
- centroid_strings.py: pull uncertain notes to the centre of confident neighbours. The
  played string on GuitarSet drops at every setting (0.878 -> <= 0.877), so the rule is
  not met and nothing changes in the product.
- README23: Guitar Pro study, MusicXML layout, .gp writer status, sync timing, hand-centre
  experiment, and measurements no devlog had covered.
- docs/PROJE_RAPORU.md: project report for the supervisor.
- Presentation: three new slides (current results, what was tried, open problems).
Product unchanged (deep2, gaps_test note F1 0.818).

Co-Authored-By: Claude Opus 5.5 <noreply@anthropic.com>
</commit_message>
<xml_diff>
--- a/inputs/Klasik_Gitar_AI_Proje_Sunumu.pptx
+++ b/inputs/Klasik_Gitar_AI_Proje_Sunumu.pptx
@@ -19,6 +19,9 @@
     <p:sldId id="267" r:id="rId18"/>
     <p:sldId id="268" r:id="rId19"/>
     <p:sldId id="269" r:id="rId20"/>
+    <p:sldId id="271" r:id="rId22"/>
+    <p:sldId id="272" r:id="rId23"/>
+    <p:sldId id="273" r:id="rId24"/>
     <p:sldId id="270" r:id="rId21"/>
   </p:sldIdLst>
   <p:sldSz cx="12191695" cy="6858000" type="screen4x3"/>
@@ -11732,6 +11735,4146 @@
                 <a:latin typeface="Segoe UI"/>
               </a:rPr>
               <a:t>https://github.com/marl/GuitarSet</a:t>
+            </a:r>
+          </a:p>
+        </p:txBody>
+      </p:sp>
+    </p:spTree>
+  </p:cSld>
+  <p:clrMapOvr>
+    <a:masterClrMapping/>
+  </p:clrMapOvr>
+</p:sld>
+</file>
+
+<file path=ppt/slides/slide16.xml><?xml version="1.0" encoding="utf-8"?>
+<p:sld xmlns:a="http://schemas.openxmlformats.org/drawingml/2006/main" xmlns:p="http://schemas.openxmlformats.org/presentationml/2006/main" xmlns:r="http://schemas.openxmlformats.org/officeDocument/2006/relationships">
+  <p:cSld>
+    <p:spTree>
+      <p:nvGrpSpPr>
+        <p:cNvPr id="1" name=""/>
+        <p:cNvGrpSpPr/>
+        <p:nvPr/>
+      </p:nvGrpSpPr>
+      <p:grpSpPr/>
+      <p:sp>
+        <p:nvSpPr>
+          <p:cNvPr id="2" name="Rectangle 1"/>
+          <p:cNvSpPr/>
+          <p:nvPr/>
+        </p:nvSpPr>
+        <p:spPr>
+          <a:xfrm>
+            <a:off x="566928" y="365760"/>
+            <a:ext cx="566928" cy="566928"/>
+          </a:xfrm>
+          <a:prstGeom prst="rect">
+            <a:avLst/>
+          </a:prstGeom>
+          <a:solidFill>
+            <a:srgbClr val="2F5D8A"/>
+          </a:solidFill>
+          <a:ln>
+            <a:noFill/>
+          </a:ln>
+          <a:effectLst/>
+        </p:spPr>
+        <p:style>
+          <a:lnRef idx="1">
+            <a:schemeClr val="accent1"/>
+          </a:lnRef>
+          <a:fillRef idx="3">
+            <a:schemeClr val="accent1"/>
+          </a:fillRef>
+          <a:effectRef idx="2">
+            <a:schemeClr val="accent1"/>
+          </a:effectRef>
+          <a:fontRef idx="minor">
+            <a:schemeClr val="lt1"/>
+          </a:fontRef>
+        </p:style>
+        <p:txBody>
+          <a:bodyPr rtlCol="0" anchor="ctr"/>
+          <a:lstStyle/>
+          <a:p>
+            <a:pPr algn="ctr"/>
+          </a:p>
+        </p:txBody>
+      </p:sp>
+      <p:sp>
+        <p:nvSpPr>
+          <p:cNvPr id="3" name="TextBox 2"/>
+          <p:cNvSpPr txBox="1"/>
+          <p:nvPr/>
+        </p:nvSpPr>
+        <p:spPr>
+          <a:xfrm>
+            <a:off x="566928" y="365760"/>
+            <a:ext cx="566928" cy="566928"/>
+          </a:xfrm>
+          <a:prstGeom prst="rect">
+            <a:avLst/>
+          </a:prstGeom>
+          <a:noFill/>
+        </p:spPr>
+        <p:txBody>
+          <a:bodyPr wrap="square" anchor="ctr" lIns="0" rIns="0" tIns="0" bIns="0">
+            <a:spAutoFit/>
+          </a:bodyPr>
+          <a:lstStyle/>
+          <a:p>
+            <a:pPr algn="ctr">
+              <a:spcBef>
+                <a:spcPts val="0"/>
+              </a:spcBef>
+              <a:spcAft>
+                <a:spcPts val="0"/>
+              </a:spcAft>
+            </a:pPr>
+            <a:r>
+              <a:rPr sz="2000" b="1" i="0">
+                <a:solidFill>
+                  <a:srgbClr val="FFFFFF"/>
+                </a:solidFill>
+                <a:latin typeface="Segoe UI"/>
+              </a:rPr>
+              <a:t>14</a:t>
+            </a:r>
+          </a:p>
+        </p:txBody>
+      </p:sp>
+      <p:sp>
+        <p:nvSpPr>
+          <p:cNvPr id="4" name="TextBox 3"/>
+          <p:cNvSpPr txBox="1"/>
+          <p:nvPr/>
+        </p:nvSpPr>
+        <p:spPr>
+          <a:xfrm>
+            <a:off x="1280160" y="329184"/>
+            <a:ext cx="10344607" cy="658368"/>
+          </a:xfrm>
+          <a:prstGeom prst="rect">
+            <a:avLst/>
+          </a:prstGeom>
+          <a:noFill/>
+        </p:spPr>
+        <p:txBody>
+          <a:bodyPr wrap="square" anchor="ctr" lIns="0" rIns="0" tIns="0" bIns="0">
+            <a:spAutoFit/>
+          </a:bodyPr>
+          <a:lstStyle/>
+          <a:p>
+            <a:pPr algn="l">
+              <a:lnSpc>
+                <a:spcPct val="100000"/>
+              </a:lnSpc>
+              <a:spcBef>
+                <a:spcPts val="0"/>
+              </a:spcBef>
+              <a:spcAft>
+                <a:spcPts val="200"/>
+              </a:spcAft>
+            </a:pPr>
+            <a:r>
+              <a:rPr sz="2400" b="1" i="0">
+                <a:solidFill>
+                  <a:srgbClr val="17365D"/>
+                </a:solidFill>
+                <a:latin typeface="Segoe UI"/>
+              </a:rPr>
+              <a:t>Gelinen Nokta: Güncel Sonuçlar (26 Ekim 2026)</a:t>
+            </a:r>
+          </a:p>
+          <a:p>
+            <a:pPr algn="l">
+              <a:lnSpc>
+                <a:spcPct val="100000"/>
+              </a:lnSpc>
+              <a:spcBef>
+                <a:spcPts val="0"/>
+              </a:spcBef>
+              <a:spcAft>
+                <a:spcPts val="0"/>
+              </a:spcAft>
+            </a:pPr>
+            <a:r>
+              <a:rPr sz="1200" b="0" i="1">
+                <a:solidFill>
+                  <a:srgbClr val="5A6472"/>
+                </a:solidFill>
+                <a:latin typeface="Segoe UI"/>
+              </a:rPr>
+              <a:t>Ürün: deep2 akustik model + iki ayrı konum modu; sayılar çalıcıdan bağımsız test setlerinde</a:t>
+            </a:r>
+          </a:p>
+        </p:txBody>
+      </p:sp>
+      <p:sp>
+        <p:nvSpPr>
+          <p:cNvPr id="5" name="Rectangle 4"/>
+          <p:cNvSpPr/>
+          <p:nvPr/>
+        </p:nvSpPr>
+        <p:spPr>
+          <a:xfrm>
+            <a:off x="566928" y="1152144"/>
+            <a:ext cx="11057839" cy="12801"/>
+          </a:xfrm>
+          <a:prstGeom prst="rect">
+            <a:avLst/>
+          </a:prstGeom>
+          <a:solidFill>
+            <a:srgbClr val="D5DEE8"/>
+          </a:solidFill>
+          <a:ln>
+            <a:noFill/>
+          </a:ln>
+          <a:effectLst/>
+        </p:spPr>
+        <p:style>
+          <a:lnRef idx="1">
+            <a:schemeClr val="accent1"/>
+          </a:lnRef>
+          <a:fillRef idx="3">
+            <a:schemeClr val="accent1"/>
+          </a:fillRef>
+          <a:effectRef idx="2">
+            <a:schemeClr val="accent1"/>
+          </a:effectRef>
+          <a:fontRef idx="minor">
+            <a:schemeClr val="lt1"/>
+          </a:fontRef>
+        </p:style>
+        <p:txBody>
+          <a:bodyPr rtlCol="0" anchor="ctr"/>
+          <a:lstStyle/>
+          <a:p>
+            <a:pPr algn="ctr"/>
+          </a:p>
+        </p:txBody>
+      </p:sp>
+      <p:sp>
+        <p:nvSpPr>
+          <p:cNvPr id="6" name="Rectangle 5"/>
+          <p:cNvSpPr/>
+          <p:nvPr/>
+        </p:nvSpPr>
+        <p:spPr>
+          <a:xfrm>
+            <a:off x="566928" y="1444752"/>
+            <a:ext cx="3564026" cy="1892807"/>
+          </a:xfrm>
+          <a:prstGeom prst="rect">
+            <a:avLst/>
+          </a:prstGeom>
+          <a:solidFill>
+            <a:srgbClr val="F1F5FA"/>
+          </a:solidFill>
+          <a:ln>
+            <a:noFill/>
+          </a:ln>
+          <a:effectLst/>
+        </p:spPr>
+        <p:style>
+          <a:lnRef idx="1">
+            <a:schemeClr val="accent1"/>
+          </a:lnRef>
+          <a:fillRef idx="3">
+            <a:schemeClr val="accent1"/>
+          </a:fillRef>
+          <a:effectRef idx="2">
+            <a:schemeClr val="accent1"/>
+          </a:effectRef>
+          <a:fontRef idx="minor">
+            <a:schemeClr val="lt1"/>
+          </a:fontRef>
+        </p:style>
+        <p:txBody>
+          <a:bodyPr rtlCol="0" anchor="ctr"/>
+          <a:lstStyle/>
+          <a:p>
+            <a:pPr algn="ctr"/>
+          </a:p>
+        </p:txBody>
+      </p:sp>
+      <p:sp>
+        <p:nvSpPr>
+          <p:cNvPr id="7" name="Rectangle 6"/>
+          <p:cNvSpPr/>
+          <p:nvPr/>
+        </p:nvSpPr>
+        <p:spPr>
+          <a:xfrm>
+            <a:off x="566928" y="1444752"/>
+            <a:ext cx="41148" cy="1892807"/>
+          </a:xfrm>
+          <a:prstGeom prst="rect">
+            <a:avLst/>
+          </a:prstGeom>
+          <a:solidFill>
+            <a:srgbClr val="2F5D8A"/>
+          </a:solidFill>
+          <a:ln>
+            <a:noFill/>
+          </a:ln>
+          <a:effectLst/>
+        </p:spPr>
+        <p:style>
+          <a:lnRef idx="1">
+            <a:schemeClr val="accent1"/>
+          </a:lnRef>
+          <a:fillRef idx="3">
+            <a:schemeClr val="accent1"/>
+          </a:fillRef>
+          <a:effectRef idx="2">
+            <a:schemeClr val="accent1"/>
+          </a:effectRef>
+          <a:fontRef idx="minor">
+            <a:schemeClr val="lt1"/>
+          </a:fontRef>
+        </p:style>
+        <p:txBody>
+          <a:bodyPr rtlCol="0" anchor="ctr"/>
+          <a:lstStyle/>
+          <a:p>
+            <a:pPr algn="ctr"/>
+          </a:p>
+        </p:txBody>
+      </p:sp>
+      <p:sp>
+        <p:nvSpPr>
+          <p:cNvPr id="8" name="TextBox 7"/>
+          <p:cNvSpPr txBox="1"/>
+          <p:nvPr/>
+        </p:nvSpPr>
+        <p:spPr>
+          <a:xfrm>
+            <a:off x="768096" y="1609344"/>
+            <a:ext cx="3198266" cy="1618487"/>
+          </a:xfrm>
+          <a:prstGeom prst="rect">
+            <a:avLst/>
+          </a:prstGeom>
+          <a:noFill/>
+        </p:spPr>
+        <p:txBody>
+          <a:bodyPr wrap="square" anchor="t" lIns="0" rIns="0" tIns="0" bIns="0">
+            <a:spAutoFit/>
+          </a:bodyPr>
+          <a:lstStyle/>
+          <a:p>
+            <a:pPr algn="l">
+              <a:lnSpc>
+                <a:spcPct val="100000"/>
+              </a:lnSpc>
+              <a:spcBef>
+                <a:spcPts val="0"/>
+              </a:spcBef>
+              <a:spcAft>
+                <a:spcPts val="100"/>
+              </a:spcAft>
+            </a:pPr>
+            <a:r>
+              <a:rPr sz="1600" b="1" i="0">
+                <a:solidFill>
+                  <a:srgbClr val="17365D"/>
+                </a:solidFill>
+                <a:latin typeface="Segoe UI"/>
+              </a:rPr>
+              <a:t>Akustik model</a:t>
+            </a:r>
+          </a:p>
+          <a:p>
+            <a:pPr algn="l">
+              <a:lnSpc>
+                <a:spcPct val="100000"/>
+              </a:lnSpc>
+              <a:spcBef>
+                <a:spcPts val="0"/>
+              </a:spcBef>
+              <a:spcAft>
+                <a:spcPts val="500"/>
+              </a:spcAft>
+            </a:pPr>
+            <a:r>
+              <a:rPr sz="1050" b="1" i="0">
+                <a:solidFill>
+                  <a:srgbClr val="B5762A"/>
+                </a:solidFill>
+                <a:latin typeface="Segoe UI"/>
+              </a:rPr>
+              <a:t>Katman 3.8–3.12</a:t>
+            </a:r>
+          </a:p>
+          <a:p>
+            <a:pPr algn="l">
+              <a:lnSpc>
+                <a:spcPct val="108000"/>
+              </a:lnSpc>
+              <a:spcBef>
+                <a:spcPts val="0"/>
+              </a:spcBef>
+              <a:spcAft>
+                <a:spcPts val="0"/>
+              </a:spcAft>
+            </a:pPr>
+            <a:r>
+              <a:rPr sz="1200" b="0" i="0">
+                <a:solidFill>
+                  <a:srgbClr val="333F4F"/>
+                </a:solidFill>
+                <a:latin typeface="Segoe UI"/>
+              </a:rPr>
+              <a:t>Derin CNN + BiLSTM + perde-onset kafası; GAPS alan uyarlaması ve alan içi kalibrasyon. GAPS nota F1 0,255 → 0,818.</a:t>
+            </a:r>
+          </a:p>
+        </p:txBody>
+      </p:sp>
+      <p:sp>
+        <p:nvSpPr>
+          <p:cNvPr id="9" name="Rectangle 8"/>
+          <p:cNvSpPr/>
+          <p:nvPr/>
+        </p:nvSpPr>
+        <p:spPr>
+          <a:xfrm>
+            <a:off x="4313834" y="1444752"/>
+            <a:ext cx="3564026" cy="1892807"/>
+          </a:xfrm>
+          <a:prstGeom prst="rect">
+            <a:avLst/>
+          </a:prstGeom>
+          <a:solidFill>
+            <a:srgbClr val="F1F5FA"/>
+          </a:solidFill>
+          <a:ln>
+            <a:noFill/>
+          </a:ln>
+          <a:effectLst/>
+        </p:spPr>
+        <p:style>
+          <a:lnRef idx="1">
+            <a:schemeClr val="accent1"/>
+          </a:lnRef>
+          <a:fillRef idx="3">
+            <a:schemeClr val="accent1"/>
+          </a:fillRef>
+          <a:effectRef idx="2">
+            <a:schemeClr val="accent1"/>
+          </a:effectRef>
+          <a:fontRef idx="minor">
+            <a:schemeClr val="lt1"/>
+          </a:fontRef>
+        </p:style>
+        <p:txBody>
+          <a:bodyPr rtlCol="0" anchor="ctr"/>
+          <a:lstStyle/>
+          <a:p>
+            <a:pPr algn="ctr"/>
+          </a:p>
+        </p:txBody>
+      </p:sp>
+      <p:sp>
+        <p:nvSpPr>
+          <p:cNvPr id="10" name="Rectangle 9"/>
+          <p:cNvSpPr/>
+          <p:nvPr/>
+        </p:nvSpPr>
+        <p:spPr>
+          <a:xfrm>
+            <a:off x="4313834" y="1444752"/>
+            <a:ext cx="41148" cy="1892807"/>
+          </a:xfrm>
+          <a:prstGeom prst="rect">
+            <a:avLst/>
+          </a:prstGeom>
+          <a:solidFill>
+            <a:srgbClr val="2F5D8A"/>
+          </a:solidFill>
+          <a:ln>
+            <a:noFill/>
+          </a:ln>
+          <a:effectLst/>
+        </p:spPr>
+        <p:style>
+          <a:lnRef idx="1">
+            <a:schemeClr val="accent1"/>
+          </a:lnRef>
+          <a:fillRef idx="3">
+            <a:schemeClr val="accent1"/>
+          </a:fillRef>
+          <a:effectRef idx="2">
+            <a:schemeClr val="accent1"/>
+          </a:effectRef>
+          <a:fontRef idx="minor">
+            <a:schemeClr val="lt1"/>
+          </a:fontRef>
+        </p:style>
+        <p:txBody>
+          <a:bodyPr rtlCol="0" anchor="ctr"/>
+          <a:lstStyle/>
+          <a:p>
+            <a:pPr algn="ctr"/>
+          </a:p>
+        </p:txBody>
+      </p:sp>
+      <p:sp>
+        <p:nvSpPr>
+          <p:cNvPr id="11" name="TextBox 10"/>
+          <p:cNvSpPr txBox="1"/>
+          <p:nvPr/>
+        </p:nvSpPr>
+        <p:spPr>
+          <a:xfrm>
+            <a:off x="4515002" y="1609344"/>
+            <a:ext cx="3198266" cy="1618487"/>
+          </a:xfrm>
+          <a:prstGeom prst="rect">
+            <a:avLst/>
+          </a:prstGeom>
+          <a:noFill/>
+        </p:spPr>
+        <p:txBody>
+          <a:bodyPr wrap="square" anchor="t" lIns="0" rIns="0" tIns="0" bIns="0">
+            <a:spAutoFit/>
+          </a:bodyPr>
+          <a:lstStyle/>
+          <a:p>
+            <a:pPr algn="l">
+              <a:lnSpc>
+                <a:spcPct val="100000"/>
+              </a:lnSpc>
+              <a:spcBef>
+                <a:spcPts val="0"/>
+              </a:spcBef>
+              <a:spcAft>
+                <a:spcPts val="100"/>
+              </a:spcAft>
+            </a:pPr>
+            <a:r>
+              <a:rPr sz="1600" b="1" i="0">
+                <a:solidFill>
+                  <a:srgbClr val="17365D"/>
+                </a:solidFill>
+                <a:latin typeface="Segoe UI"/>
+              </a:rPr>
+              <a:t>İki konum modu</a:t>
+            </a:r>
+          </a:p>
+          <a:p>
+            <a:pPr algn="l">
+              <a:lnSpc>
+                <a:spcPct val="100000"/>
+              </a:lnSpc>
+              <a:spcBef>
+                <a:spcPts val="0"/>
+              </a:spcBef>
+              <a:spcAft>
+                <a:spcPts val="500"/>
+              </a:spcAft>
+            </a:pPr>
+            <a:r>
+              <a:rPr sz="1050" b="1" i="0">
+                <a:solidFill>
+                  <a:srgbClr val="B5762A"/>
+                </a:solidFill>
+                <a:latin typeface="Segoe UI"/>
+              </a:rPr>
+              <a:t>Katman 3.13</a:t>
+            </a:r>
+          </a:p>
+          <a:p>
+            <a:pPr algn="l">
+              <a:lnSpc>
+                <a:spcPct val="108000"/>
+              </a:lnSpc>
+              <a:spcBef>
+                <a:spcPts val="0"/>
+              </a:spcBef>
+              <a:spcAft>
+                <a:spcPts val="0"/>
+              </a:spcAft>
+            </a:pPr>
+            <a:r>
+              <a:rPr sz="1200" b="0" i="0">
+                <a:solidFill>
+                  <a:srgbClr val="333F4F"/>
+                </a:solidFill>
+                <a:latin typeface="Segoe UI"/>
+              </a:rPr>
+              <a:t>Duyulan konum (sesten) ve klasik edisyon önerisi (tel + perde + sol el parmağı) bilinçli olarak ayrı tutuldu.</a:t>
+            </a:r>
+          </a:p>
+        </p:txBody>
+      </p:sp>
+      <p:sp>
+        <p:nvSpPr>
+          <p:cNvPr id="12" name="Rectangle 11"/>
+          <p:cNvSpPr/>
+          <p:nvPr/>
+        </p:nvSpPr>
+        <p:spPr>
+          <a:xfrm>
+            <a:off x="8060740" y="1444752"/>
+            <a:ext cx="3564026" cy="1892807"/>
+          </a:xfrm>
+          <a:prstGeom prst="rect">
+            <a:avLst/>
+          </a:prstGeom>
+          <a:solidFill>
+            <a:srgbClr val="F1F5FA"/>
+          </a:solidFill>
+          <a:ln>
+            <a:noFill/>
+          </a:ln>
+          <a:effectLst/>
+        </p:spPr>
+        <p:style>
+          <a:lnRef idx="1">
+            <a:schemeClr val="accent1"/>
+          </a:lnRef>
+          <a:fillRef idx="3">
+            <a:schemeClr val="accent1"/>
+          </a:fillRef>
+          <a:effectRef idx="2">
+            <a:schemeClr val="accent1"/>
+          </a:effectRef>
+          <a:fontRef idx="minor">
+            <a:schemeClr val="lt1"/>
+          </a:fontRef>
+        </p:style>
+        <p:txBody>
+          <a:bodyPr rtlCol="0" anchor="ctr"/>
+          <a:lstStyle/>
+          <a:p>
+            <a:pPr algn="ctr"/>
+          </a:p>
+        </p:txBody>
+      </p:sp>
+      <p:sp>
+        <p:nvSpPr>
+          <p:cNvPr id="13" name="Rectangle 12"/>
+          <p:cNvSpPr/>
+          <p:nvPr/>
+        </p:nvSpPr>
+        <p:spPr>
+          <a:xfrm>
+            <a:off x="8060740" y="1444752"/>
+            <a:ext cx="41148" cy="1892807"/>
+          </a:xfrm>
+          <a:prstGeom prst="rect">
+            <a:avLst/>
+          </a:prstGeom>
+          <a:solidFill>
+            <a:srgbClr val="2F5D8A"/>
+          </a:solidFill>
+          <a:ln>
+            <a:noFill/>
+          </a:ln>
+          <a:effectLst/>
+        </p:spPr>
+        <p:style>
+          <a:lnRef idx="1">
+            <a:schemeClr val="accent1"/>
+          </a:lnRef>
+          <a:fillRef idx="3">
+            <a:schemeClr val="accent1"/>
+          </a:fillRef>
+          <a:effectRef idx="2">
+            <a:schemeClr val="accent1"/>
+          </a:effectRef>
+          <a:fontRef idx="minor">
+            <a:schemeClr val="lt1"/>
+          </a:fontRef>
+        </p:style>
+        <p:txBody>
+          <a:bodyPr rtlCol="0" anchor="ctr"/>
+          <a:lstStyle/>
+          <a:p>
+            <a:pPr algn="ctr"/>
+          </a:p>
+        </p:txBody>
+      </p:sp>
+      <p:sp>
+        <p:nvSpPr>
+          <p:cNvPr id="14" name="TextBox 13"/>
+          <p:cNvSpPr txBox="1"/>
+          <p:nvPr/>
+        </p:nvSpPr>
+        <p:spPr>
+          <a:xfrm>
+            <a:off x="8261908" y="1609344"/>
+            <a:ext cx="3198266" cy="1618487"/>
+          </a:xfrm>
+          <a:prstGeom prst="rect">
+            <a:avLst/>
+          </a:prstGeom>
+          <a:noFill/>
+        </p:spPr>
+        <p:txBody>
+          <a:bodyPr wrap="square" anchor="t" lIns="0" rIns="0" tIns="0" bIns="0">
+            <a:spAutoFit/>
+          </a:bodyPr>
+          <a:lstStyle/>
+          <a:p>
+            <a:pPr algn="l">
+              <a:lnSpc>
+                <a:spcPct val="100000"/>
+              </a:lnSpc>
+              <a:spcBef>
+                <a:spcPts val="0"/>
+              </a:spcBef>
+              <a:spcAft>
+                <a:spcPts val="100"/>
+              </a:spcAft>
+            </a:pPr>
+            <a:r>
+              <a:rPr sz="1600" b="1" i="0">
+                <a:solidFill>
+                  <a:srgbClr val="17365D"/>
+                </a:solidFill>
+                <a:latin typeface="Segoe UI"/>
+              </a:rPr>
+              <a:t>Ritim ve çıktı</a:t>
+            </a:r>
+          </a:p>
+          <a:p>
+            <a:pPr algn="l">
+              <a:lnSpc>
+                <a:spcPct val="100000"/>
+              </a:lnSpc>
+              <a:spcBef>
+                <a:spcPts val="0"/>
+              </a:spcBef>
+              <a:spcAft>
+                <a:spcPts val="500"/>
+              </a:spcAft>
+            </a:pPr>
+            <a:r>
+              <a:rPr sz="1050" b="1" i="0">
+                <a:solidFill>
+                  <a:srgbClr val="B5762A"/>
+                </a:solidFill>
+                <a:latin typeface="Segoe UI"/>
+              </a:rPr>
+              <a:t>Katman 5–6</a:t>
+            </a:r>
+          </a:p>
+          <a:p>
+            <a:pPr algn="l">
+              <a:lnSpc>
+                <a:spcPct val="108000"/>
+              </a:lnSpc>
+              <a:spcBef>
+                <a:spcPts val="0"/>
+              </a:spcBef>
+              <a:spcAft>
+                <a:spcPts val="0"/>
+              </a:spcAft>
+            </a:pPr>
+            <a:r>
+              <a:rPr sz="1200" b="0" i="0">
+                <a:solidFill>
+                  <a:srgbClr val="333F4F"/>
+                </a:solidFill>
+                <a:latin typeface="Segoe UI"/>
+              </a:rPr>
+              <a:t>Yarı otomatik vuruş + bağlamlı kuantalayıcı; MusicXML / alphaTab çıktısı, akort ve kapo, şarkılı kayıtta vokal ayırma.</a:t>
+            </a:r>
+          </a:p>
+        </p:txBody>
+      </p:sp>
+      <p:sp>
+        <p:nvSpPr>
+          <p:cNvPr id="15" name="TextBox 14"/>
+          <p:cNvSpPr txBox="1"/>
+          <p:nvPr/>
+        </p:nvSpPr>
+        <p:spPr>
+          <a:xfrm>
+            <a:off x="566928" y="3474719"/>
+            <a:ext cx="11057839" cy="237744"/>
+          </a:xfrm>
+          <a:prstGeom prst="rect">
+            <a:avLst/>
+          </a:prstGeom>
+          <a:noFill/>
+        </p:spPr>
+        <p:txBody>
+          <a:bodyPr wrap="square" anchor="ctr" lIns="0" rIns="0" tIns="0" bIns="0">
+            <a:spAutoFit/>
+          </a:bodyPr>
+          <a:lstStyle/>
+          <a:p>
+            <a:pPr algn="ctr">
+              <a:spcBef>
+                <a:spcPts val="0"/>
+              </a:spcBef>
+              <a:spcAft>
+                <a:spcPts val="0"/>
+              </a:spcAft>
+            </a:pPr>
+            <a:r>
+              <a:rPr sz="1000" b="1" i="0">
+                <a:solidFill>
+                  <a:srgbClr val="5A6472"/>
+                </a:solidFill>
+                <a:latin typeface="Segoe UI"/>
+              </a:rPr>
+              <a:t>GÜNCEL ÖLÇÜMLER — GAPS TEST (GERÇEK KLASİK GİTAR) VE KENDİ KAYITLARIMIZ</a:t>
+            </a:r>
+          </a:p>
+        </p:txBody>
+      </p:sp>
+      <p:sp>
+        <p:nvSpPr>
+          <p:cNvPr id="16" name="Rectangle 15"/>
+          <p:cNvSpPr/>
+          <p:nvPr/>
+        </p:nvSpPr>
+        <p:spPr>
+          <a:xfrm>
+            <a:off x="566928" y="3849623"/>
+            <a:ext cx="3564026" cy="1234440"/>
+          </a:xfrm>
+          <a:prstGeom prst="rect">
+            <a:avLst/>
+          </a:prstGeom>
+          <a:solidFill>
+            <a:srgbClr val="FBF3E6"/>
+          </a:solidFill>
+          <a:ln>
+            <a:noFill/>
+          </a:ln>
+          <a:effectLst/>
+        </p:spPr>
+        <p:style>
+          <a:lnRef idx="1">
+            <a:schemeClr val="accent1"/>
+          </a:lnRef>
+          <a:fillRef idx="3">
+            <a:schemeClr val="accent1"/>
+          </a:fillRef>
+          <a:effectRef idx="2">
+            <a:schemeClr val="accent1"/>
+          </a:effectRef>
+          <a:fontRef idx="minor">
+            <a:schemeClr val="lt1"/>
+          </a:fontRef>
+        </p:style>
+        <p:txBody>
+          <a:bodyPr rtlCol="0" anchor="ctr"/>
+          <a:lstStyle/>
+          <a:p>
+            <a:pPr algn="ctr"/>
+          </a:p>
+        </p:txBody>
+      </p:sp>
+      <p:sp>
+        <p:nvSpPr>
+          <p:cNvPr id="17" name="TextBox 16"/>
+          <p:cNvSpPr txBox="1"/>
+          <p:nvPr/>
+        </p:nvSpPr>
+        <p:spPr>
+          <a:xfrm>
+            <a:off x="566928" y="3849623"/>
+            <a:ext cx="3564026" cy="1234440"/>
+          </a:xfrm>
+          <a:prstGeom prst="rect">
+            <a:avLst/>
+          </a:prstGeom>
+          <a:noFill/>
+        </p:spPr>
+        <p:txBody>
+          <a:bodyPr wrap="square" anchor="ctr" lIns="0" rIns="0" tIns="0" bIns="0">
+            <a:spAutoFit/>
+          </a:bodyPr>
+          <a:lstStyle/>
+          <a:p>
+            <a:pPr algn="ctr">
+              <a:lnSpc>
+                <a:spcPct val="100000"/>
+              </a:lnSpc>
+              <a:spcBef>
+                <a:spcPts val="0"/>
+              </a:spcBef>
+              <a:spcAft>
+                <a:spcPts val="200"/>
+              </a:spcAft>
+            </a:pPr>
+            <a:r>
+              <a:rPr sz="2700" b="1" i="0">
+                <a:solidFill>
+                  <a:srgbClr val="B5762A"/>
+                </a:solidFill>
+                <a:latin typeface="Segoe UI"/>
+              </a:rPr>
+              <a:t>%81,8</a:t>
+            </a:r>
+          </a:p>
+          <a:p>
+            <a:pPr algn="ctr">
+              <a:lnSpc>
+                <a:spcPct val="100000"/>
+              </a:lnSpc>
+              <a:spcBef>
+                <a:spcPts val="0"/>
+              </a:spcBef>
+              <a:spcAft>
+                <a:spcPts val="0"/>
+              </a:spcAft>
+            </a:pPr>
+            <a:r>
+              <a:rPr sz="1100" b="0" i="0">
+                <a:solidFill>
+                  <a:srgbClr val="5A6472"/>
+                </a:solidFill>
+                <a:latin typeface="Segoe UI"/>
+              </a:rPr>
+              <a:t>Nota F1 (GAPS test)</a:t>
+            </a:r>
+          </a:p>
+        </p:txBody>
+      </p:sp>
+      <p:sp>
+        <p:nvSpPr>
+          <p:cNvPr id="18" name="Rectangle 17"/>
+          <p:cNvSpPr/>
+          <p:nvPr/>
+        </p:nvSpPr>
+        <p:spPr>
+          <a:xfrm>
+            <a:off x="4313834" y="3849623"/>
+            <a:ext cx="3564026" cy="1234440"/>
+          </a:xfrm>
+          <a:prstGeom prst="rect">
+            <a:avLst/>
+          </a:prstGeom>
+          <a:solidFill>
+            <a:srgbClr val="FBF3E6"/>
+          </a:solidFill>
+          <a:ln>
+            <a:noFill/>
+          </a:ln>
+          <a:effectLst/>
+        </p:spPr>
+        <p:style>
+          <a:lnRef idx="1">
+            <a:schemeClr val="accent1"/>
+          </a:lnRef>
+          <a:fillRef idx="3">
+            <a:schemeClr val="accent1"/>
+          </a:fillRef>
+          <a:effectRef idx="2">
+            <a:schemeClr val="accent1"/>
+          </a:effectRef>
+          <a:fontRef idx="minor">
+            <a:schemeClr val="lt1"/>
+          </a:fontRef>
+        </p:style>
+        <p:txBody>
+          <a:bodyPr rtlCol="0" anchor="ctr"/>
+          <a:lstStyle/>
+          <a:p>
+            <a:pPr algn="ctr"/>
+          </a:p>
+        </p:txBody>
+      </p:sp>
+      <p:sp>
+        <p:nvSpPr>
+          <p:cNvPr id="19" name="TextBox 18"/>
+          <p:cNvSpPr txBox="1"/>
+          <p:nvPr/>
+        </p:nvSpPr>
+        <p:spPr>
+          <a:xfrm>
+            <a:off x="4313834" y="3849623"/>
+            <a:ext cx="3564026" cy="1234440"/>
+          </a:xfrm>
+          <a:prstGeom prst="rect">
+            <a:avLst/>
+          </a:prstGeom>
+          <a:noFill/>
+        </p:spPr>
+        <p:txBody>
+          <a:bodyPr wrap="square" anchor="ctr" lIns="0" rIns="0" tIns="0" bIns="0">
+            <a:spAutoFit/>
+          </a:bodyPr>
+          <a:lstStyle/>
+          <a:p>
+            <a:pPr algn="ctr">
+              <a:lnSpc>
+                <a:spcPct val="100000"/>
+              </a:lnSpc>
+              <a:spcBef>
+                <a:spcPts val="0"/>
+              </a:spcBef>
+              <a:spcAft>
+                <a:spcPts val="200"/>
+              </a:spcAft>
+            </a:pPr>
+            <a:r>
+              <a:rPr sz="2700" b="1" i="0">
+                <a:solidFill>
+                  <a:srgbClr val="B5762A"/>
+                </a:solidFill>
+                <a:latin typeface="Segoe UI"/>
+              </a:rPr>
+              <a:t>%83,1</a:t>
+            </a:r>
+          </a:p>
+          <a:p>
+            <a:pPr algn="ctr">
+              <a:lnSpc>
+                <a:spcPct val="100000"/>
+              </a:lnSpc>
+              <a:spcBef>
+                <a:spcPts val="0"/>
+              </a:spcBef>
+              <a:spcAft>
+                <a:spcPts val="0"/>
+              </a:spcAft>
+            </a:pPr>
+            <a:r>
+              <a:rPr sz="1100" b="0" i="0">
+                <a:solidFill>
+                  <a:srgbClr val="5A6472"/>
+                </a:solidFill>
+                <a:latin typeface="Segoe UI"/>
+              </a:rPr>
+              <a:t>Edisyon tel uyumu (GAPS test)</a:t>
+            </a:r>
+          </a:p>
+        </p:txBody>
+      </p:sp>
+      <p:sp>
+        <p:nvSpPr>
+          <p:cNvPr id="20" name="Rectangle 19"/>
+          <p:cNvSpPr/>
+          <p:nvPr/>
+        </p:nvSpPr>
+        <p:spPr>
+          <a:xfrm>
+            <a:off x="8060740" y="3849623"/>
+            <a:ext cx="3564026" cy="1234440"/>
+          </a:xfrm>
+          <a:prstGeom prst="rect">
+            <a:avLst/>
+          </a:prstGeom>
+          <a:solidFill>
+            <a:srgbClr val="FBF3E6"/>
+          </a:solidFill>
+          <a:ln>
+            <a:noFill/>
+          </a:ln>
+          <a:effectLst/>
+        </p:spPr>
+        <p:style>
+          <a:lnRef idx="1">
+            <a:schemeClr val="accent1"/>
+          </a:lnRef>
+          <a:fillRef idx="3">
+            <a:schemeClr val="accent1"/>
+          </a:fillRef>
+          <a:effectRef idx="2">
+            <a:schemeClr val="accent1"/>
+          </a:effectRef>
+          <a:fontRef idx="minor">
+            <a:schemeClr val="lt1"/>
+          </a:fontRef>
+        </p:style>
+        <p:txBody>
+          <a:bodyPr rtlCol="0" anchor="ctr"/>
+          <a:lstStyle/>
+          <a:p>
+            <a:pPr algn="ctr"/>
+          </a:p>
+        </p:txBody>
+      </p:sp>
+      <p:sp>
+        <p:nvSpPr>
+          <p:cNvPr id="21" name="TextBox 20"/>
+          <p:cNvSpPr txBox="1"/>
+          <p:nvPr/>
+        </p:nvSpPr>
+        <p:spPr>
+          <a:xfrm>
+            <a:off x="8060740" y="3849623"/>
+            <a:ext cx="3564026" cy="1234440"/>
+          </a:xfrm>
+          <a:prstGeom prst="rect">
+            <a:avLst/>
+          </a:prstGeom>
+          <a:noFill/>
+        </p:spPr>
+        <p:txBody>
+          <a:bodyPr wrap="square" anchor="ctr" lIns="0" rIns="0" tIns="0" bIns="0">
+            <a:spAutoFit/>
+          </a:bodyPr>
+          <a:lstStyle/>
+          <a:p>
+            <a:pPr algn="ctr">
+              <a:lnSpc>
+                <a:spcPct val="100000"/>
+              </a:lnSpc>
+              <a:spcBef>
+                <a:spcPts val="0"/>
+              </a:spcBef>
+              <a:spcAft>
+                <a:spcPts val="200"/>
+              </a:spcAft>
+            </a:pPr>
+            <a:r>
+              <a:rPr sz="2700" b="1" i="0">
+                <a:solidFill>
+                  <a:srgbClr val="B5762A"/>
+                </a:solidFill>
+                <a:latin typeface="Segoe UI"/>
+              </a:rPr>
+              <a:t>%36</a:t>
+            </a:r>
+          </a:p>
+          <a:p>
+            <a:pPr algn="ctr">
+              <a:lnSpc>
+                <a:spcPct val="100000"/>
+              </a:lnSpc>
+              <a:spcBef>
+                <a:spcPts val="0"/>
+              </a:spcBef>
+              <a:spcAft>
+                <a:spcPts val="0"/>
+              </a:spcAft>
+            </a:pPr>
+            <a:r>
+              <a:rPr sz="1100" b="0" i="0">
+                <a:solidFill>
+                  <a:srgbClr val="5A6472"/>
+                </a:solidFill>
+                <a:latin typeface="Segoe UI"/>
+              </a:rPr>
+              <a:t>Sesten çalınan tel (kendi kayıt T02; şans ≈ %33)</a:t>
+            </a:r>
+          </a:p>
+        </p:txBody>
+      </p:sp>
+      <p:sp>
+        <p:nvSpPr>
+          <p:cNvPr id="22" name="Rectangle 21"/>
+          <p:cNvSpPr/>
+          <p:nvPr/>
+        </p:nvSpPr>
+        <p:spPr>
+          <a:xfrm>
+            <a:off x="566928" y="5221223"/>
+            <a:ext cx="11057839" cy="749808"/>
+          </a:xfrm>
+          <a:prstGeom prst="rect">
+            <a:avLst/>
+          </a:prstGeom>
+          <a:solidFill>
+            <a:srgbClr val="F1F5FA"/>
+          </a:solidFill>
+          <a:ln>
+            <a:noFill/>
+          </a:ln>
+          <a:effectLst/>
+        </p:spPr>
+        <p:style>
+          <a:lnRef idx="1">
+            <a:schemeClr val="accent1"/>
+          </a:lnRef>
+          <a:fillRef idx="3">
+            <a:schemeClr val="accent1"/>
+          </a:fillRef>
+          <a:effectRef idx="2">
+            <a:schemeClr val="accent1"/>
+          </a:effectRef>
+          <a:fontRef idx="minor">
+            <a:schemeClr val="lt1"/>
+          </a:fontRef>
+        </p:style>
+        <p:txBody>
+          <a:bodyPr rtlCol="0" anchor="ctr"/>
+          <a:lstStyle/>
+          <a:p>
+            <a:pPr algn="ctr"/>
+          </a:p>
+        </p:txBody>
+      </p:sp>
+      <p:sp>
+        <p:nvSpPr>
+          <p:cNvPr id="23" name="Rectangle 22"/>
+          <p:cNvSpPr/>
+          <p:nvPr/>
+        </p:nvSpPr>
+        <p:spPr>
+          <a:xfrm>
+            <a:off x="566928" y="5221223"/>
+            <a:ext cx="50292" cy="749808"/>
+          </a:xfrm>
+          <a:prstGeom prst="rect">
+            <a:avLst/>
+          </a:prstGeom>
+          <a:solidFill>
+            <a:srgbClr val="2F5D8A"/>
+          </a:solidFill>
+          <a:ln>
+            <a:noFill/>
+          </a:ln>
+          <a:effectLst/>
+        </p:spPr>
+        <p:style>
+          <a:lnRef idx="1">
+            <a:schemeClr val="accent1"/>
+          </a:lnRef>
+          <a:fillRef idx="3">
+            <a:schemeClr val="accent1"/>
+          </a:fillRef>
+          <a:effectRef idx="2">
+            <a:schemeClr val="accent1"/>
+          </a:effectRef>
+          <a:fontRef idx="minor">
+            <a:schemeClr val="lt1"/>
+          </a:fontRef>
+        </p:style>
+        <p:txBody>
+          <a:bodyPr rtlCol="0" anchor="ctr"/>
+          <a:lstStyle/>
+          <a:p>
+            <a:pPr algn="ctr"/>
+          </a:p>
+        </p:txBody>
+      </p:sp>
+      <p:sp>
+        <p:nvSpPr>
+          <p:cNvPr id="24" name="TextBox 23"/>
+          <p:cNvSpPr txBox="1"/>
+          <p:nvPr/>
+        </p:nvSpPr>
+        <p:spPr>
+          <a:xfrm>
+            <a:off x="786384" y="5221223"/>
+            <a:ext cx="10655503" cy="749808"/>
+          </a:xfrm>
+          <a:prstGeom prst="rect">
+            <a:avLst/>
+          </a:prstGeom>
+          <a:noFill/>
+        </p:spPr>
+        <p:txBody>
+          <a:bodyPr wrap="square" anchor="ctr" lIns="0" rIns="0" tIns="0" bIns="0">
+            <a:spAutoFit/>
+          </a:bodyPr>
+          <a:lstStyle/>
+          <a:p>
+            <a:pPr algn="l">
+              <a:lnSpc>
+                <a:spcPct val="106000"/>
+              </a:lnSpc>
+              <a:spcBef>
+                <a:spcPts val="0"/>
+              </a:spcBef>
+              <a:spcAft>
+                <a:spcPts val="0"/>
+              </a:spcAft>
+            </a:pPr>
+            <a:r>
+              <a:rPr sz="1250" b="0" i="0">
+                <a:solidFill>
+                  <a:srgbClr val="333F4F"/>
+                </a:solidFill>
+                <a:latin typeface="Segoe UI"/>
+              </a:rPr>
+              <a:t>Ders: Nota bulma ve yazılı edisyon güçlü; asıl açık, klasik gitarda çalınan teli sesten ayırmak. GuitarSet'teki %87,8 çelik tel içindir, klasik gitar sayısı değildir.</a:t>
+            </a:r>
+          </a:p>
+        </p:txBody>
+      </p:sp>
+      <p:sp>
+        <p:nvSpPr>
+          <p:cNvPr id="25" name="TextBox 24"/>
+          <p:cNvSpPr txBox="1"/>
+          <p:nvPr/>
+        </p:nvSpPr>
+        <p:spPr>
+          <a:xfrm>
+            <a:off x="566928" y="6108191"/>
+            <a:ext cx="11057839" cy="310896"/>
+          </a:xfrm>
+          <a:prstGeom prst="rect">
+            <a:avLst/>
+          </a:prstGeom>
+          <a:noFill/>
+        </p:spPr>
+        <p:txBody>
+          <a:bodyPr wrap="square" anchor="ctr" lIns="0" rIns="0" tIns="0" bIns="0">
+            <a:spAutoFit/>
+          </a:bodyPr>
+          <a:lstStyle/>
+          <a:p>
+            <a:pPr algn="l">
+              <a:lnSpc>
+                <a:spcPct val="105000"/>
+              </a:lnSpc>
+              <a:spcBef>
+                <a:spcPts val="0"/>
+              </a:spcBef>
+              <a:spcAft>
+                <a:spcPts val="0"/>
+              </a:spcAft>
+            </a:pPr>
+            <a:r>
+              <a:rPr sz="900" b="0" i="0">
+                <a:solidFill>
+                  <a:srgbClr val="5A6472"/>
+                </a:solidFill>
+                <a:latin typeface="Segoe UI"/>
+              </a:rPr>
+              <a:t>Ayrıntı: docs/PROJE_RAPORU.md ve docs/devlog/README1–23.md — eşikler yalnız doğrulamada seçildi, test setleri yalnız raporlandı</a:t>
+            </a:r>
+          </a:p>
+        </p:txBody>
+      </p:sp>
+    </p:spTree>
+  </p:cSld>
+  <p:clrMapOvr>
+    <a:masterClrMapping/>
+  </p:clrMapOvr>
+</p:sld>
+</file>
+
+<file path=ppt/slides/slide17.xml><?xml version="1.0" encoding="utf-8"?>
+<p:sld xmlns:a="http://schemas.openxmlformats.org/drawingml/2006/main" xmlns:p="http://schemas.openxmlformats.org/presentationml/2006/main" xmlns:r="http://schemas.openxmlformats.org/officeDocument/2006/relationships">
+  <p:cSld>
+    <p:spTree>
+      <p:nvGrpSpPr>
+        <p:cNvPr id="1" name=""/>
+        <p:cNvGrpSpPr/>
+        <p:nvPr/>
+      </p:nvGrpSpPr>
+      <p:grpSpPr/>
+      <p:sp>
+        <p:nvSpPr>
+          <p:cNvPr id="2" name="Rectangle 1"/>
+          <p:cNvSpPr/>
+          <p:nvPr/>
+        </p:nvSpPr>
+        <p:spPr>
+          <a:xfrm>
+            <a:off x="566928" y="365760"/>
+            <a:ext cx="566928" cy="566928"/>
+          </a:xfrm>
+          <a:prstGeom prst="rect">
+            <a:avLst/>
+          </a:prstGeom>
+          <a:solidFill>
+            <a:srgbClr val="2F5D8A"/>
+          </a:solidFill>
+          <a:ln>
+            <a:noFill/>
+          </a:ln>
+          <a:effectLst/>
+        </p:spPr>
+        <p:style>
+          <a:lnRef idx="1">
+            <a:schemeClr val="accent1"/>
+          </a:lnRef>
+          <a:fillRef idx="3">
+            <a:schemeClr val="accent1"/>
+          </a:fillRef>
+          <a:effectRef idx="2">
+            <a:schemeClr val="accent1"/>
+          </a:effectRef>
+          <a:fontRef idx="minor">
+            <a:schemeClr val="lt1"/>
+          </a:fontRef>
+        </p:style>
+        <p:txBody>
+          <a:bodyPr rtlCol="0" anchor="ctr"/>
+          <a:lstStyle/>
+          <a:p>
+            <a:pPr algn="ctr"/>
+          </a:p>
+        </p:txBody>
+      </p:sp>
+      <p:sp>
+        <p:nvSpPr>
+          <p:cNvPr id="3" name="TextBox 2"/>
+          <p:cNvSpPr txBox="1"/>
+          <p:nvPr/>
+        </p:nvSpPr>
+        <p:spPr>
+          <a:xfrm>
+            <a:off x="566928" y="365760"/>
+            <a:ext cx="566928" cy="566928"/>
+          </a:xfrm>
+          <a:prstGeom prst="rect">
+            <a:avLst/>
+          </a:prstGeom>
+          <a:noFill/>
+        </p:spPr>
+        <p:txBody>
+          <a:bodyPr wrap="square" anchor="ctr" lIns="0" rIns="0" tIns="0" bIns="0">
+            <a:spAutoFit/>
+          </a:bodyPr>
+          <a:lstStyle/>
+          <a:p>
+            <a:pPr algn="ctr">
+              <a:spcBef>
+                <a:spcPts val="0"/>
+              </a:spcBef>
+              <a:spcAft>
+                <a:spcPts val="0"/>
+              </a:spcAft>
+            </a:pPr>
+            <a:r>
+              <a:rPr sz="2000" b="1" i="0">
+                <a:solidFill>
+                  <a:srgbClr val="FFFFFF"/>
+                </a:solidFill>
+                <a:latin typeface="Segoe UI"/>
+              </a:rPr>
+              <a:t>15</a:t>
+            </a:r>
+          </a:p>
+        </p:txBody>
+      </p:sp>
+      <p:sp>
+        <p:nvSpPr>
+          <p:cNvPr id="4" name="TextBox 3"/>
+          <p:cNvSpPr txBox="1"/>
+          <p:nvPr/>
+        </p:nvSpPr>
+        <p:spPr>
+          <a:xfrm>
+            <a:off x="1280160" y="329184"/>
+            <a:ext cx="10344607" cy="658368"/>
+          </a:xfrm>
+          <a:prstGeom prst="rect">
+            <a:avLst/>
+          </a:prstGeom>
+          <a:noFill/>
+        </p:spPr>
+        <p:txBody>
+          <a:bodyPr wrap="square" anchor="ctr" lIns="0" rIns="0" tIns="0" bIns="0">
+            <a:spAutoFit/>
+          </a:bodyPr>
+          <a:lstStyle/>
+          <a:p>
+            <a:pPr algn="l">
+              <a:lnSpc>
+                <a:spcPct val="100000"/>
+              </a:lnSpc>
+              <a:spcBef>
+                <a:spcPts val="0"/>
+              </a:spcBef>
+              <a:spcAft>
+                <a:spcPts val="200"/>
+              </a:spcAft>
+            </a:pPr>
+            <a:r>
+              <a:rPr sz="2400" b="1" i="0">
+                <a:solidFill>
+                  <a:srgbClr val="17365D"/>
+                </a:solidFill>
+                <a:latin typeface="Segoe UI"/>
+              </a:rPr>
+              <a:t>Neler Denendi, Ne Oldu</a:t>
+            </a:r>
+          </a:p>
+          <a:p>
+            <a:pPr algn="l">
+              <a:lnSpc>
+                <a:spcPct val="100000"/>
+              </a:lnSpc>
+              <a:spcBef>
+                <a:spcPts val="0"/>
+              </a:spcBef>
+              <a:spcAft>
+                <a:spcPts val="0"/>
+              </a:spcAft>
+            </a:pPr>
+            <a:r>
+              <a:rPr sz="1200" b="0" i="1">
+                <a:solidFill>
+                  <a:srgbClr val="5A6472"/>
+                </a:solidFill>
+                <a:latin typeface="Segoe UI"/>
+              </a:rPr>
+              <a:t>Her adımın kabul kuralı ölçümden önce yazıldı; işe yaramayan denemeler de kayıtta</a:t>
+            </a:r>
+          </a:p>
+        </p:txBody>
+      </p:sp>
+      <p:sp>
+        <p:nvSpPr>
+          <p:cNvPr id="5" name="Rectangle 4"/>
+          <p:cNvSpPr/>
+          <p:nvPr/>
+        </p:nvSpPr>
+        <p:spPr>
+          <a:xfrm>
+            <a:off x="566928" y="1152144"/>
+            <a:ext cx="11057839" cy="12801"/>
+          </a:xfrm>
+          <a:prstGeom prst="rect">
+            <a:avLst/>
+          </a:prstGeom>
+          <a:solidFill>
+            <a:srgbClr val="D5DEE8"/>
+          </a:solidFill>
+          <a:ln>
+            <a:noFill/>
+          </a:ln>
+          <a:effectLst/>
+        </p:spPr>
+        <p:style>
+          <a:lnRef idx="1">
+            <a:schemeClr val="accent1"/>
+          </a:lnRef>
+          <a:fillRef idx="3">
+            <a:schemeClr val="accent1"/>
+          </a:fillRef>
+          <a:effectRef idx="2">
+            <a:schemeClr val="accent1"/>
+          </a:effectRef>
+          <a:fontRef idx="minor">
+            <a:schemeClr val="lt1"/>
+          </a:fontRef>
+        </p:style>
+        <p:txBody>
+          <a:bodyPr rtlCol="0" anchor="ctr"/>
+          <a:lstStyle/>
+          <a:p>
+            <a:pPr algn="ctr"/>
+          </a:p>
+        </p:txBody>
+      </p:sp>
+      <p:graphicFrame>
+        <p:nvGraphicFramePr>
+          <p:cNvPr id="6" name="Table 5"/>
+          <p:cNvGraphicFramePr>
+            <a:graphicFrameLocks noGrp="1"/>
+          </p:cNvGraphicFramePr>
+          <p:nvPr/>
+        </p:nvGraphicFramePr>
+        <p:xfrm>
+          <a:off x="566928" y="1444752"/>
+          <a:ext cx="11057837" cy="3858765"/>
+        </p:xfrm>
+        <a:graphic>
+          <a:graphicData uri="http://schemas.openxmlformats.org/drawingml/2006/table">
+            <a:tbl>
+              <a:tblPr>
+                <a:tableStyleId>{5C22544A-7EE6-4342-B048-85BDC9FD1C3A}</a:tableStyleId>
+              </a:tblPr>
+              <a:tblGrid>
+                <a:gridCol w="2137229"/>
+                <a:gridCol w="3159382"/>
+                <a:gridCol w="2973536"/>
+                <a:gridCol w="2787690"/>
+              </a:tblGrid>
+              <a:tr h="475488">
+                <a:tc>
+                  <a:txBody>
+                    <a:bodyPr wrap="square"/>
+                    <a:lstStyle/>
+                    <a:p>
+                      <a:pPr algn="l">
+                        <a:lnSpc>
+                          <a:spcPct val="105000"/>
+                        </a:lnSpc>
+                        <a:spcBef>
+                          <a:spcPts val="0"/>
+                        </a:spcBef>
+                        <a:spcAft>
+                          <a:spcPts val="0"/>
+                        </a:spcAft>
+                      </a:pPr>
+                      <a:r>
+                        <a:rPr sz="1200" b="1" i="0">
+                          <a:solidFill>
+                            <a:srgbClr val="FFFFFF"/>
+                          </a:solidFill>
+                          <a:latin typeface="Segoe UI"/>
+                        </a:rPr>
+                        <a:t>Deneme</a:t>
+                      </a:r>
+                    </a:p>
+                  </a:txBody>
+                  <a:tcPr marL="118872" marR="118872" marT="36576" marB="36576">
+                    <a:solidFill>
+                      <a:srgbClr val="2F5D8A"/>
+                    </a:solidFill>
+                  </a:tcPr>
+                </a:tc>
+                <a:tc>
+                  <a:txBody>
+                    <a:bodyPr wrap="square"/>
+                    <a:lstStyle/>
+                    <a:p>
+                      <a:pPr algn="l">
+                        <a:lnSpc>
+                          <a:spcPct val="105000"/>
+                        </a:lnSpc>
+                        <a:spcBef>
+                          <a:spcPts val="0"/>
+                        </a:spcBef>
+                        <a:spcAft>
+                          <a:spcPts val="0"/>
+                        </a:spcAft>
+                      </a:pPr>
+                      <a:r>
+                        <a:rPr sz="1200" b="1" i="0">
+                          <a:solidFill>
+                            <a:srgbClr val="FFFFFF"/>
+                          </a:solidFill>
+                          <a:latin typeface="Segoe UI"/>
+                        </a:rPr>
+                        <a:t>Ne yapıldı</a:t>
+                      </a:r>
+                    </a:p>
+                  </a:txBody>
+                  <a:tcPr marL="118872" marR="118872" marT="36576" marB="36576">
+                    <a:solidFill>
+                      <a:srgbClr val="2F5D8A"/>
+                    </a:solidFill>
+                  </a:tcPr>
+                </a:tc>
+                <a:tc>
+                  <a:txBody>
+                    <a:bodyPr wrap="square"/>
+                    <a:lstStyle/>
+                    <a:p>
+                      <a:pPr algn="l">
+                        <a:lnSpc>
+                          <a:spcPct val="105000"/>
+                        </a:lnSpc>
+                        <a:spcBef>
+                          <a:spcPts val="0"/>
+                        </a:spcBef>
+                        <a:spcAft>
+                          <a:spcPts val="0"/>
+                        </a:spcAft>
+                      </a:pPr>
+                      <a:r>
+                        <a:rPr sz="1200" b="1" i="0">
+                          <a:solidFill>
+                            <a:srgbClr val="FFFFFF"/>
+                          </a:solidFill>
+                          <a:latin typeface="Segoe UI"/>
+                        </a:rPr>
+                        <a:t>Sonuç</a:t>
+                      </a:r>
+                    </a:p>
+                  </a:txBody>
+                  <a:tcPr marL="118872" marR="118872" marT="36576" marB="36576">
+                    <a:solidFill>
+                      <a:srgbClr val="2F5D8A"/>
+                    </a:solidFill>
+                  </a:tcPr>
+                </a:tc>
+                <a:tc>
+                  <a:txBody>
+                    <a:bodyPr wrap="square"/>
+                    <a:lstStyle/>
+                    <a:p>
+                      <a:pPr algn="l">
+                        <a:lnSpc>
+                          <a:spcPct val="105000"/>
+                        </a:lnSpc>
+                        <a:spcBef>
+                          <a:spcPts val="0"/>
+                        </a:spcBef>
+                        <a:spcAft>
+                          <a:spcPts val="0"/>
+                        </a:spcAft>
+                      </a:pPr>
+                      <a:r>
+                        <a:rPr sz="1200" b="1" i="0">
+                          <a:solidFill>
+                            <a:srgbClr val="FFFFFF"/>
+                          </a:solidFill>
+                          <a:latin typeface="Segoe UI"/>
+                        </a:rPr>
+                        <a:t>Karar</a:t>
+                      </a:r>
+                    </a:p>
+                  </a:txBody>
+                  <a:tcPr marL="118872" marR="118872" marT="36576" marB="36576">
+                    <a:solidFill>
+                      <a:srgbClr val="2F5D8A"/>
+                    </a:solidFill>
+                  </a:tcPr>
+                </a:tc>
+              </a:tr>
+              <a:tr h="483000">
+                <a:tc>
+                  <a:txBody>
+                    <a:bodyPr wrap="square"/>
+                    <a:lstStyle/>
+                    <a:p>
+                      <a:pPr algn="l">
+                        <a:lnSpc>
+                          <a:spcPct val="105000"/>
+                        </a:lnSpc>
+                        <a:spcBef>
+                          <a:spcPts val="0"/>
+                        </a:spcBef>
+                        <a:spcAft>
+                          <a:spcPts val="0"/>
+                        </a:spcAft>
+                      </a:pPr>
+                      <a:r>
+                        <a:rPr sz="1100" b="1" i="0">
+                          <a:solidFill>
+                            <a:srgbClr val="17365D"/>
+                          </a:solidFill>
+                          <a:latin typeface="Segoe UI"/>
+                        </a:rPr>
+                        <a:t>Klasik gitara uyarlama (3.8)</a:t>
+                      </a:r>
+                    </a:p>
+                  </a:txBody>
+                  <a:tcPr marL="118872" marR="118872" marT="36576" marB="36576">
+                    <a:solidFill>
+                      <a:srgbClr val="F1F5FA"/>
+                    </a:solidFill>
+                  </a:tcPr>
+                </a:tc>
+                <a:tc>
+                  <a:txBody>
+                    <a:bodyPr wrap="square"/>
+                    <a:lstStyle/>
+                    <a:p>
+                      <a:pPr algn="l">
+                        <a:lnSpc>
+                          <a:spcPct val="105000"/>
+                        </a:lnSpc>
+                        <a:spcBef>
+                          <a:spcPts val="0"/>
+                        </a:spcBef>
+                        <a:spcAft>
+                          <a:spcPts val="0"/>
+                        </a:spcAft>
+                      </a:pPr>
+                      <a:r>
+                        <a:rPr sz="1100" b="0" i="0">
+                          <a:solidFill>
+                            <a:srgbClr val="333F4F"/>
+                          </a:solidFill>
+                          <a:latin typeface="Segoe UI"/>
+                        </a:rPr>
+                        <a:t>GAPS perde etiketiyle ince ayar</a:t>
+                      </a:r>
+                    </a:p>
+                  </a:txBody>
+                  <a:tcPr marL="118872" marR="118872" marT="36576" marB="36576">
+                    <a:solidFill>
+                      <a:srgbClr val="F1F5FA"/>
+                    </a:solidFill>
+                  </a:tcPr>
+                </a:tc>
+                <a:tc>
+                  <a:txBody>
+                    <a:bodyPr wrap="square"/>
+                    <a:lstStyle/>
+                    <a:p>
+                      <a:pPr algn="l">
+                        <a:lnSpc>
+                          <a:spcPct val="105000"/>
+                        </a:lnSpc>
+                        <a:spcBef>
+                          <a:spcPts val="0"/>
+                        </a:spcBef>
+                        <a:spcAft>
+                          <a:spcPts val="0"/>
+                        </a:spcAft>
+                      </a:pPr>
+                      <a:r>
+                        <a:rPr sz="1100" b="0" i="0">
+                          <a:solidFill>
+                            <a:srgbClr val="333F4F"/>
+                          </a:solidFill>
+                          <a:latin typeface="Segoe UI"/>
+                        </a:rPr>
+                        <a:t>GAPS nota F1 0,255 → 0,360; GuitarSet teli de arttı</a:t>
+                      </a:r>
+                    </a:p>
+                  </a:txBody>
+                  <a:tcPr marL="118872" marR="118872" marT="36576" marB="36576">
+                    <a:solidFill>
+                      <a:srgbClr val="F1F5FA"/>
+                    </a:solidFill>
+                  </a:tcPr>
+                </a:tc>
+                <a:tc>
+                  <a:txBody>
+                    <a:bodyPr wrap="square"/>
+                    <a:lstStyle/>
+                    <a:p>
+                      <a:pPr algn="l">
+                        <a:lnSpc>
+                          <a:spcPct val="105000"/>
+                        </a:lnSpc>
+                        <a:spcBef>
+                          <a:spcPts val="0"/>
+                        </a:spcBef>
+                        <a:spcAft>
+                          <a:spcPts val="0"/>
+                        </a:spcAft>
+                      </a:pPr>
+                      <a:r>
+                        <a:rPr sz="1100" b="0" i="0">
+                          <a:solidFill>
+                            <a:srgbClr val="333F4F"/>
+                          </a:solidFill>
+                          <a:latin typeface="Segoe UI"/>
+                        </a:rPr>
+                        <a:t>Kabul</a:t>
+                      </a:r>
+                    </a:p>
+                  </a:txBody>
+                  <a:tcPr marL="118872" marR="118872" marT="36576" marB="36576">
+                    <a:solidFill>
+                      <a:srgbClr val="F1F5FA"/>
+                    </a:solidFill>
+                  </a:tcPr>
+                </a:tc>
+              </a:tr>
+              <a:tr h="483000">
+                <a:tc>
+                  <a:txBody>
+                    <a:bodyPr wrap="square"/>
+                    <a:lstStyle/>
+                    <a:p>
+                      <a:pPr algn="l">
+                        <a:lnSpc>
+                          <a:spcPct val="105000"/>
+                        </a:lnSpc>
+                        <a:spcBef>
+                          <a:spcPts val="0"/>
+                        </a:spcBef>
+                        <a:spcAft>
+                          <a:spcPts val="0"/>
+                        </a:spcAft>
+                      </a:pPr>
+                      <a:r>
+                        <a:rPr sz="1100" b="1" i="0">
+                          <a:solidFill>
+                            <a:srgbClr val="17365D"/>
+                          </a:solidFill>
+                          <a:latin typeface="Segoe UI"/>
+                        </a:rPr>
+                        <a:t>Onset + kalibrasyon (3.9–3.11)</a:t>
+                      </a:r>
+                    </a:p>
+                  </a:txBody>
+                  <a:tcPr marL="118872" marR="118872" marT="36576" marB="36576">
+                    <a:solidFill>
+                      <a:srgbClr val="F1F5FA"/>
+                    </a:solidFill>
+                  </a:tcPr>
+                </a:tc>
+                <a:tc>
+                  <a:txBody>
+                    <a:bodyPr wrap="square"/>
+                    <a:lstStyle/>
+                    <a:p>
+                      <a:pPr algn="l">
+                        <a:lnSpc>
+                          <a:spcPct val="105000"/>
+                        </a:lnSpc>
+                        <a:spcBef>
+                          <a:spcPts val="0"/>
+                        </a:spcBef>
+                        <a:spcAft>
+                          <a:spcPts val="0"/>
+                        </a:spcAft>
+                      </a:pPr>
+                      <a:r>
+                        <a:rPr sz="1100" b="0" i="0">
+                          <a:solidFill>
+                            <a:srgbClr val="333F4F"/>
+                          </a:solidFill>
+                          <a:latin typeface="Segoe UI"/>
+                        </a:rPr>
+                        <a:t>Onset kafası, harmonik istifleme, alan içi eşik</a:t>
+                      </a:r>
+                    </a:p>
+                  </a:txBody>
+                  <a:tcPr marL="118872" marR="118872" marT="36576" marB="36576">
+                    <a:solidFill>
+                      <a:srgbClr val="F1F5FA"/>
+                    </a:solidFill>
+                  </a:tcPr>
+                </a:tc>
+                <a:tc>
+                  <a:txBody>
+                    <a:bodyPr wrap="square"/>
+                    <a:lstStyle/>
+                    <a:p>
+                      <a:pPr algn="l">
+                        <a:lnSpc>
+                          <a:spcPct val="105000"/>
+                        </a:lnSpc>
+                        <a:spcBef>
+                          <a:spcPts val="0"/>
+                        </a:spcBef>
+                        <a:spcAft>
+                          <a:spcPts val="0"/>
+                        </a:spcAft>
+                      </a:pPr>
+                      <a:r>
+                        <a:rPr sz="1100" b="0" i="0">
+                          <a:solidFill>
+                            <a:srgbClr val="333F4F"/>
+                          </a:solidFill>
+                          <a:latin typeface="Segoe UI"/>
+                        </a:rPr>
+                        <a:t>Akor nota F1 0,46 → 0,72; GAPS 0,44 → 0,72</a:t>
+                      </a:r>
+                    </a:p>
+                  </a:txBody>
+                  <a:tcPr marL="118872" marR="118872" marT="36576" marB="36576">
+                    <a:solidFill>
+                      <a:srgbClr val="F1F5FA"/>
+                    </a:solidFill>
+                  </a:tcPr>
+                </a:tc>
+                <a:tc>
+                  <a:txBody>
+                    <a:bodyPr wrap="square"/>
+                    <a:lstStyle/>
+                    <a:p>
+                      <a:pPr algn="l">
+                        <a:lnSpc>
+                          <a:spcPct val="105000"/>
+                        </a:lnSpc>
+                        <a:spcBef>
+                          <a:spcPts val="0"/>
+                        </a:spcBef>
+                        <a:spcAft>
+                          <a:spcPts val="0"/>
+                        </a:spcAft>
+                      </a:pPr>
+                      <a:r>
+                        <a:rPr sz="1100" b="0" i="0">
+                          <a:solidFill>
+                            <a:srgbClr val="333F4F"/>
+                          </a:solidFill>
+                          <a:latin typeface="Segoe UI"/>
+                        </a:rPr>
+                        <a:t>Kabul</a:t>
+                      </a:r>
+                    </a:p>
+                  </a:txBody>
+                  <a:tcPr marL="118872" marR="118872" marT="36576" marB="36576">
+                    <a:solidFill>
+                      <a:srgbClr val="F1F5FA"/>
+                    </a:solidFill>
+                  </a:tcPr>
+                </a:tc>
+              </a:tr>
+              <a:tr h="483000">
+                <a:tc>
+                  <a:txBody>
+                    <a:bodyPr wrap="square"/>
+                    <a:lstStyle/>
+                    <a:p>
+                      <a:pPr algn="l">
+                        <a:lnSpc>
+                          <a:spcPct val="105000"/>
+                        </a:lnSpc>
+                        <a:spcBef>
+                          <a:spcPts val="0"/>
+                        </a:spcBef>
+                        <a:spcAft>
+                          <a:spcPts val="0"/>
+                        </a:spcAft>
+                      </a:pPr>
+                      <a:r>
+                        <a:rPr sz="1100" b="1" i="0">
+                          <a:solidFill>
+                            <a:srgbClr val="17365D"/>
+                          </a:solidFill>
+                          <a:latin typeface="Segoe UI"/>
+                        </a:rPr>
+                        <a:t>Kapasite artışı (3.12)</a:t>
+                      </a:r>
+                    </a:p>
+                  </a:txBody>
+                  <a:tcPr marL="118872" marR="118872" marT="36576" marB="36576">
+                    <a:solidFill>
+                      <a:srgbClr val="F1F5FA"/>
+                    </a:solidFill>
+                  </a:tcPr>
+                </a:tc>
+                <a:tc>
+                  <a:txBody>
+                    <a:bodyPr wrap="square"/>
+                    <a:lstStyle/>
+                    <a:p>
+                      <a:pPr algn="l">
+                        <a:lnSpc>
+                          <a:spcPct val="105000"/>
+                        </a:lnSpc>
+                        <a:spcBef>
+                          <a:spcPts val="0"/>
+                        </a:spcBef>
+                        <a:spcAft>
+                          <a:spcPts val="0"/>
+                        </a:spcAft>
+                      </a:pPr>
+                      <a:r>
+                        <a:rPr sz="1100" b="0" i="0">
+                          <a:solidFill>
+                            <a:srgbClr val="333F4F"/>
+                          </a:solidFill>
+                          <a:latin typeface="Segoe UI"/>
+                        </a:rPr>
+                        <a:t>Derin CNN + perde-onset kafası (deep2)</a:t>
+                      </a:r>
+                    </a:p>
+                  </a:txBody>
+                  <a:tcPr marL="118872" marR="118872" marT="36576" marB="36576">
+                    <a:solidFill>
+                      <a:srgbClr val="F1F5FA"/>
+                    </a:solidFill>
+                  </a:tcPr>
+                </a:tc>
+                <a:tc>
+                  <a:txBody>
+                    <a:bodyPr wrap="square"/>
+                    <a:lstStyle/>
+                    <a:p>
+                      <a:pPr algn="l">
+                        <a:lnSpc>
+                          <a:spcPct val="105000"/>
+                        </a:lnSpc>
+                        <a:spcBef>
+                          <a:spcPts val="0"/>
+                        </a:spcBef>
+                        <a:spcAft>
+                          <a:spcPts val="0"/>
+                        </a:spcAft>
+                      </a:pPr>
+                      <a:r>
+                        <a:rPr sz="1100" b="0" i="0">
+                          <a:solidFill>
+                            <a:srgbClr val="333F4F"/>
+                          </a:solidFill>
+                          <a:latin typeface="Segoe UI"/>
+                        </a:rPr>
+                        <a:t>GAPS nota F1 0,720 → 0,779</a:t>
+                      </a:r>
+                    </a:p>
+                  </a:txBody>
+                  <a:tcPr marL="118872" marR="118872" marT="36576" marB="36576">
+                    <a:solidFill>
+                      <a:srgbClr val="F1F5FA"/>
+                    </a:solidFill>
+                  </a:tcPr>
+                </a:tc>
+                <a:tc>
+                  <a:txBody>
+                    <a:bodyPr wrap="square"/>
+                    <a:lstStyle/>
+                    <a:p>
+                      <a:pPr algn="l">
+                        <a:lnSpc>
+                          <a:spcPct val="105000"/>
+                        </a:lnSpc>
+                        <a:spcBef>
+                          <a:spcPts val="0"/>
+                        </a:spcBef>
+                        <a:spcAft>
+                          <a:spcPts val="0"/>
+                        </a:spcAft>
+                      </a:pPr>
+                      <a:r>
+                        <a:rPr sz="1100" b="0" i="0">
+                          <a:solidFill>
+                            <a:srgbClr val="333F4F"/>
+                          </a:solidFill>
+                          <a:latin typeface="Segoe UI"/>
+                        </a:rPr>
+                        <a:t>Kabul — ürün modeli</a:t>
+                      </a:r>
+                    </a:p>
+                  </a:txBody>
+                  <a:tcPr marL="118872" marR="118872" marT="36576" marB="36576">
+                    <a:solidFill>
+                      <a:srgbClr val="F1F5FA"/>
+                    </a:solidFill>
+                  </a:tcPr>
+                </a:tc>
+              </a:tr>
+              <a:tr h="483000">
+                <a:tc>
+                  <a:txBody>
+                    <a:bodyPr wrap="square"/>
+                    <a:lstStyle/>
+                    <a:p>
+                      <a:pPr algn="l">
+                        <a:lnSpc>
+                          <a:spcPct val="105000"/>
+                        </a:lnSpc>
+                        <a:spcBef>
+                          <a:spcPts val="0"/>
+                        </a:spcBef>
+                        <a:spcAft>
+                          <a:spcPts val="0"/>
+                        </a:spcAft>
+                      </a:pPr>
+                      <a:r>
+                        <a:rPr sz="1100" b="1" i="0">
+                          <a:solidFill>
+                            <a:srgbClr val="17365D"/>
+                          </a:solidFill>
+                          <a:latin typeface="Segoe UI"/>
+                        </a:rPr>
+                        <a:t>Edisyon modu (3.13)</a:t>
+                      </a:r>
+                    </a:p>
+                  </a:txBody>
+                  <a:tcPr marL="118872" marR="118872" marT="36576" marB="36576">
+                    <a:solidFill>
+                      <a:srgbClr val="F1F5FA"/>
+                    </a:solidFill>
+                  </a:tcPr>
+                </a:tc>
+                <a:tc>
+                  <a:txBody>
+                    <a:bodyPr wrap="square"/>
+                    <a:lstStyle/>
+                    <a:p>
+                      <a:pPr algn="l">
+                        <a:lnSpc>
+                          <a:spcPct val="105000"/>
+                        </a:lnSpc>
+                        <a:spcBef>
+                          <a:spcPts val="0"/>
+                        </a:spcBef>
+                        <a:spcAft>
+                          <a:spcPts val="0"/>
+                        </a:spcAft>
+                      </a:pPr>
+                      <a:r>
+                        <a:rPr sz="1100" b="0" i="0">
+                          <a:solidFill>
+                            <a:srgbClr val="333F4F"/>
+                          </a:solidFill>
+                          <a:latin typeface="Segoe UI"/>
+                        </a:rPr>
+                        <a:t>Sessiz BiLSTM: tel + perde + parmak</a:t>
+                      </a:r>
+                    </a:p>
+                  </a:txBody>
+                  <a:tcPr marL="118872" marR="118872" marT="36576" marB="36576">
+                    <a:solidFill>
+                      <a:srgbClr val="F1F5FA"/>
+                    </a:solidFill>
+                  </a:tcPr>
+                </a:tc>
+                <a:tc>
+                  <a:txBody>
+                    <a:bodyPr wrap="square"/>
+                    <a:lstStyle/>
+                    <a:p>
+                      <a:pPr algn="l">
+                        <a:lnSpc>
+                          <a:spcPct val="105000"/>
+                        </a:lnSpc>
+                        <a:spcBef>
+                          <a:spcPts val="0"/>
+                        </a:spcBef>
+                        <a:spcAft>
+                          <a:spcPts val="0"/>
+                        </a:spcAft>
+                      </a:pPr>
+                      <a:r>
+                        <a:rPr sz="1100" b="0" i="0">
+                          <a:solidFill>
+                            <a:srgbClr val="333F4F"/>
+                          </a:solidFill>
+                          <a:latin typeface="Segoe UI"/>
+                        </a:rPr>
+                        <a:t>Yazılı tab teli 0,745 → 0,831; parmak 0,566 → 0,636</a:t>
+                      </a:r>
+                    </a:p>
+                  </a:txBody>
+                  <a:tcPr marL="118872" marR="118872" marT="36576" marB="36576">
+                    <a:solidFill>
+                      <a:srgbClr val="F1F5FA"/>
+                    </a:solidFill>
+                  </a:tcPr>
+                </a:tc>
+                <a:tc>
+                  <a:txBody>
+                    <a:bodyPr wrap="square"/>
+                    <a:lstStyle/>
+                    <a:p>
+                      <a:pPr algn="l">
+                        <a:lnSpc>
+                          <a:spcPct val="105000"/>
+                        </a:lnSpc>
+                        <a:spcBef>
+                          <a:spcPts val="0"/>
+                        </a:spcBef>
+                        <a:spcAft>
+                          <a:spcPts val="0"/>
+                        </a:spcAft>
+                      </a:pPr>
+                      <a:r>
+                        <a:rPr sz="1100" b="0" i="0">
+                          <a:solidFill>
+                            <a:srgbClr val="333F4F"/>
+                          </a:solidFill>
+                          <a:latin typeface="Segoe UI"/>
+                        </a:rPr>
+                        <a:t>Kabul — ayrı mod</a:t>
+                      </a:r>
+                    </a:p>
+                  </a:txBody>
+                  <a:tcPr marL="118872" marR="118872" marT="36576" marB="36576">
+                    <a:solidFill>
+                      <a:srgbClr val="F1F5FA"/>
+                    </a:solidFill>
+                  </a:tcPr>
+                </a:tc>
+              </a:tr>
+              <a:tr h="483000">
+                <a:tc>
+                  <a:txBody>
+                    <a:bodyPr wrap="square"/>
+                    <a:lstStyle/>
+                    <a:p>
+                      <a:pPr algn="l">
+                        <a:lnSpc>
+                          <a:spcPct val="105000"/>
+                        </a:lnSpc>
+                        <a:spcBef>
+                          <a:spcPts val="0"/>
+                        </a:spcBef>
+                        <a:spcAft>
+                          <a:spcPts val="0"/>
+                        </a:spcAft>
+                      </a:pPr>
+                      <a:r>
+                        <a:rPr sz="1100" b="1" i="0">
+                          <a:solidFill>
+                            <a:srgbClr val="17365D"/>
+                          </a:solidFill>
+                          <a:latin typeface="Segoe UI"/>
+                        </a:rPr>
+                        <a:t>Çözümleme düzeltmeleri</a:t>
+                      </a:r>
+                    </a:p>
+                  </a:txBody>
+                  <a:tcPr marL="118872" marR="118872" marT="36576" marB="36576">
+                    <a:solidFill>
+                      <a:srgbClr val="F1F5FA"/>
+                    </a:solidFill>
+                  </a:tcPr>
+                </a:tc>
+                <a:tc>
+                  <a:txBody>
+                    <a:bodyPr wrap="square"/>
+                    <a:lstStyle/>
+                    <a:p>
+                      <a:pPr algn="l">
+                        <a:lnSpc>
+                          <a:spcPct val="105000"/>
+                        </a:lnSpc>
+                        <a:spcBef>
+                          <a:spcPts val="0"/>
+                        </a:spcBef>
+                        <a:spcAft>
+                          <a:spcPts val="0"/>
+                        </a:spcAft>
+                      </a:pPr>
+                      <a:r>
+                        <a:rPr sz="1100" b="0" i="0">
+                          <a:solidFill>
+                            <a:srgbClr val="333F4F"/>
+                          </a:solidFill>
+                          <a:latin typeface="Segoe UI"/>
+                        </a:rPr>
+                        <a:t>Yeniden vuruş kapısı, akor kısıtı, enerji şartı</a:t>
+                      </a:r>
+                    </a:p>
+                  </a:txBody>
+                  <a:tcPr marL="118872" marR="118872" marT="36576" marB="36576">
+                    <a:solidFill>
+                      <a:srgbClr val="F1F5FA"/>
+                    </a:solidFill>
+                  </a:tcPr>
+                </a:tc>
+                <a:tc>
+                  <a:txBody>
+                    <a:bodyPr wrap="square"/>
+                    <a:lstStyle/>
+                    <a:p>
+                      <a:pPr algn="l">
+                        <a:lnSpc>
+                          <a:spcPct val="105000"/>
+                        </a:lnSpc>
+                        <a:spcBef>
+                          <a:spcPts val="0"/>
+                        </a:spcBef>
+                        <a:spcAft>
+                          <a:spcPts val="0"/>
+                        </a:spcAft>
+                      </a:pPr>
+                      <a:r>
+                        <a:rPr sz="1100" b="0" i="0">
+                          <a:solidFill>
+                            <a:srgbClr val="333F4F"/>
+                          </a:solidFill>
+                          <a:latin typeface="Segoe UI"/>
+                        </a:rPr>
+                        <a:t>Aynı tel çakışması 641 → 0; nota F1 0,779 → 0,818</a:t>
+                      </a:r>
+                    </a:p>
+                  </a:txBody>
+                  <a:tcPr marL="118872" marR="118872" marT="36576" marB="36576">
+                    <a:solidFill>
+                      <a:srgbClr val="F1F5FA"/>
+                    </a:solidFill>
+                  </a:tcPr>
+                </a:tc>
+                <a:tc>
+                  <a:txBody>
+                    <a:bodyPr wrap="square"/>
+                    <a:lstStyle/>
+                    <a:p>
+                      <a:pPr algn="l">
+                        <a:lnSpc>
+                          <a:spcPct val="105000"/>
+                        </a:lnSpc>
+                        <a:spcBef>
+                          <a:spcPts val="0"/>
+                        </a:spcBef>
+                        <a:spcAft>
+                          <a:spcPts val="0"/>
+                        </a:spcAft>
+                      </a:pPr>
+                      <a:r>
+                        <a:rPr sz="1100" b="0" i="0">
+                          <a:solidFill>
+                            <a:srgbClr val="333F4F"/>
+                          </a:solidFill>
+                          <a:latin typeface="Segoe UI"/>
+                        </a:rPr>
+                        <a:t>Kabul</a:t>
+                      </a:r>
+                    </a:p>
+                  </a:txBody>
+                  <a:tcPr marL="118872" marR="118872" marT="36576" marB="36576">
+                    <a:solidFill>
+                      <a:srgbClr val="F1F5FA"/>
+                    </a:solidFill>
+                  </a:tcPr>
+                </a:tc>
+              </a:tr>
+              <a:tr h="483000">
+                <a:tc>
+                  <a:txBody>
+                    <a:bodyPr wrap="square"/>
+                    <a:lstStyle/>
+                    <a:p>
+                      <a:pPr algn="l">
+                        <a:lnSpc>
+                          <a:spcPct val="105000"/>
+                        </a:lnSpc>
+                        <a:spcBef>
+                          <a:spcPts val="0"/>
+                        </a:spcBef>
+                        <a:spcAft>
+                          <a:spcPts val="0"/>
+                        </a:spcAft>
+                      </a:pPr>
+                      <a:r>
+                        <a:rPr sz="1100" b="1" i="0">
+                          <a:solidFill>
+                            <a:srgbClr val="17365D"/>
+                          </a:solidFill>
+                          <a:latin typeface="Segoe UI"/>
+                        </a:rPr>
+                        <a:t>Bağlam kuralları</a:t>
+                      </a:r>
+                    </a:p>
+                  </a:txBody>
+                  <a:tcPr marL="118872" marR="118872" marT="36576" marB="36576">
+                    <a:solidFill>
+                      <a:srgbClr val="F1F5FA"/>
+                    </a:solidFill>
+                  </a:tcPr>
+                </a:tc>
+                <a:tc>
+                  <a:txBody>
+                    <a:bodyPr wrap="square"/>
+                    <a:lstStyle/>
+                    <a:p>
+                      <a:pPr algn="l">
+                        <a:lnSpc>
+                          <a:spcPct val="105000"/>
+                        </a:lnSpc>
+                        <a:spcBef>
+                          <a:spcPts val="0"/>
+                        </a:spcBef>
+                        <a:spcAft>
+                          <a:spcPts val="0"/>
+                        </a:spcAft>
+                      </a:pPr>
+                      <a:r>
+                        <a:rPr sz="1100" b="0" i="0">
+                          <a:solidFill>
+                            <a:srgbClr val="333F4F"/>
+                          </a:solidFill>
+                          <a:latin typeface="Segoe UI"/>
+                        </a:rPr>
+                        <a:t>El pozisyonu önseli, hibrit mod, tel merkezi</a:t>
+                      </a:r>
+                    </a:p>
+                  </a:txBody>
+                  <a:tcPr marL="118872" marR="118872" marT="36576" marB="36576">
+                    <a:solidFill>
+                      <a:srgbClr val="F1F5FA"/>
+                    </a:solidFill>
+                  </a:tcPr>
+                </a:tc>
+                <a:tc>
+                  <a:txBody>
+                    <a:bodyPr wrap="square"/>
+                    <a:lstStyle/>
+                    <a:p>
+                      <a:pPr algn="l">
+                        <a:lnSpc>
+                          <a:spcPct val="105000"/>
+                        </a:lnSpc>
+                        <a:spcBef>
+                          <a:spcPts val="0"/>
+                        </a:spcBef>
+                        <a:spcAft>
+                          <a:spcPts val="0"/>
+                        </a:spcAft>
+                      </a:pPr>
+                      <a:r>
+                        <a:rPr sz="1100" b="0" i="0">
+                          <a:solidFill>
+                            <a:srgbClr val="333F4F"/>
+                          </a:solidFill>
+                          <a:latin typeface="Segoe UI"/>
+                        </a:rPr>
+                        <a:t>Çalınan tel (GuitarSet) 0,878 → ≤ 0,877</a:t>
+                      </a:r>
+                    </a:p>
+                  </a:txBody>
+                  <a:tcPr marL="118872" marR="118872" marT="36576" marB="36576">
+                    <a:solidFill>
+                      <a:srgbClr val="F1F5FA"/>
+                    </a:solidFill>
+                  </a:tcPr>
+                </a:tc>
+                <a:tc>
+                  <a:txBody>
+                    <a:bodyPr wrap="square"/>
+                    <a:lstStyle/>
+                    <a:p>
+                      <a:pPr algn="l">
+                        <a:lnSpc>
+                          <a:spcPct val="105000"/>
+                        </a:lnSpc>
+                        <a:spcBef>
+                          <a:spcPts val="0"/>
+                        </a:spcBef>
+                        <a:spcAft>
+                          <a:spcPts val="0"/>
+                        </a:spcAft>
+                      </a:pPr>
+                      <a:r>
+                        <a:rPr sz="1100" b="0" i="0">
+                          <a:solidFill>
+                            <a:srgbClr val="333F4F"/>
+                          </a:solidFill>
+                          <a:latin typeface="Segoe UI"/>
+                        </a:rPr>
+                        <a:t>Red</a:t>
+                      </a:r>
+                    </a:p>
+                  </a:txBody>
+                  <a:tcPr marL="118872" marR="118872" marT="36576" marB="36576">
+                    <a:solidFill>
+                      <a:srgbClr val="F1F5FA"/>
+                    </a:solidFill>
+                  </a:tcPr>
+                </a:tc>
+              </a:tr>
+              <a:tr h="483000">
+                <a:tc>
+                  <a:txBody>
+                    <a:bodyPr wrap="square"/>
+                    <a:lstStyle/>
+                    <a:p>
+                      <a:pPr algn="l">
+                        <a:lnSpc>
+                          <a:spcPct val="105000"/>
+                        </a:lnSpc>
+                        <a:spcBef>
+                          <a:spcPts val="0"/>
+                        </a:spcBef>
+                        <a:spcAft>
+                          <a:spcPts val="0"/>
+                        </a:spcAft>
+                      </a:pPr>
+                      <a:r>
+                        <a:rPr sz="1100" b="1" i="0">
+                          <a:solidFill>
+                            <a:srgbClr val="17365D"/>
+                          </a:solidFill>
+                          <a:latin typeface="Segoe UI"/>
+                        </a:rPr>
+                        <a:t>Ek eğitim / tel uzmanı</a:t>
+                      </a:r>
+                    </a:p>
+                  </a:txBody>
+                  <a:tcPr marL="118872" marR="118872" marT="36576" marB="36576">
+                    <a:solidFill>
+                      <a:srgbClr val="F1F5FA"/>
+                    </a:solidFill>
+                  </a:tcPr>
+                </a:tc>
+                <a:tc>
+                  <a:txBody>
+                    <a:bodyPr wrap="square"/>
+                    <a:lstStyle/>
+                    <a:p>
+                      <a:pPr algn="l">
+                        <a:lnSpc>
+                          <a:spcPct val="105000"/>
+                        </a:lnSpc>
+                        <a:spcBef>
+                          <a:spcPts val="0"/>
+                        </a:spcBef>
+                        <a:spcAft>
+                          <a:spcPts val="0"/>
+                        </a:spcAft>
+                      </a:pPr>
+                      <a:r>
+                        <a:rPr sz="1100" b="0" i="0">
+                          <a:solidFill>
+                            <a:srgbClr val="333F4F"/>
+                          </a:solidFill>
+                          <a:latin typeface="Segoe UI"/>
+                        </a:rPr>
+                        <a:t>Partisyon TAB'ı, dayanıklılık, hayalet cezası, YouTube tel verisi</a:t>
+                      </a:r>
+                    </a:p>
+                  </a:txBody>
+                  <a:tcPr marL="118872" marR="118872" marT="36576" marB="36576">
+                    <a:solidFill>
+                      <a:srgbClr val="F1F5FA"/>
+                    </a:solidFill>
+                  </a:tcPr>
+                </a:tc>
+                <a:tc>
+                  <a:txBody>
+                    <a:bodyPr wrap="square"/>
+                    <a:lstStyle/>
+                    <a:p>
+                      <a:pPr algn="l">
+                        <a:lnSpc>
+                          <a:spcPct val="105000"/>
+                        </a:lnSpc>
+                        <a:spcBef>
+                          <a:spcPts val="0"/>
+                        </a:spcBef>
+                        <a:spcAft>
+                          <a:spcPts val="0"/>
+                        </a:spcAft>
+                      </a:pPr>
+                      <a:r>
+                        <a:rPr sz="1100" b="0" i="0">
+                          <a:solidFill>
+                            <a:srgbClr val="333F4F"/>
+                          </a:solidFill>
+                          <a:latin typeface="Segoe UI"/>
+                        </a:rPr>
+                        <a:t>Genelleme yok ya da GuitarSet kaybı</a:t>
+                      </a:r>
+                    </a:p>
+                  </a:txBody>
+                  <a:tcPr marL="118872" marR="118872" marT="36576" marB="36576">
+                    <a:solidFill>
+                      <a:srgbClr val="F1F5FA"/>
+                    </a:solidFill>
+                  </a:tcPr>
+                </a:tc>
+                <a:tc>
+                  <a:txBody>
+                    <a:bodyPr wrap="square"/>
+                    <a:lstStyle/>
+                    <a:p>
+                      <a:pPr algn="l">
+                        <a:lnSpc>
+                          <a:spcPct val="105000"/>
+                        </a:lnSpc>
+                        <a:spcBef>
+                          <a:spcPts val="0"/>
+                        </a:spcBef>
+                        <a:spcAft>
+                          <a:spcPts val="0"/>
+                        </a:spcAft>
+                      </a:pPr>
+                      <a:r>
+                        <a:rPr sz="1100" b="0" i="0">
+                          <a:solidFill>
+                            <a:srgbClr val="333F4F"/>
+                          </a:solidFill>
+                          <a:latin typeface="Segoe UI"/>
+                        </a:rPr>
+                        <a:t>Red</a:t>
+                      </a:r>
+                    </a:p>
+                  </a:txBody>
+                  <a:tcPr marL="118872" marR="118872" marT="36576" marB="36576">
+                    <a:solidFill>
+                      <a:srgbClr val="F1F5FA"/>
+                    </a:solidFill>
+                  </a:tcPr>
+                </a:tc>
+              </a:tr>
+            </a:tbl>
+          </a:graphicData>
+        </a:graphic>
+      </p:graphicFrame>
+      <p:sp>
+        <p:nvSpPr>
+          <p:cNvPr id="7" name="Rectangle 6"/>
+          <p:cNvSpPr/>
+          <p:nvPr/>
+        </p:nvSpPr>
+        <p:spPr>
+          <a:xfrm>
+            <a:off x="566928" y="5440679"/>
+            <a:ext cx="11057839" cy="530352"/>
+          </a:xfrm>
+          <a:prstGeom prst="rect">
+            <a:avLst/>
+          </a:prstGeom>
+          <a:solidFill>
+            <a:srgbClr val="F1F5FA"/>
+          </a:solidFill>
+          <a:ln>
+            <a:noFill/>
+          </a:ln>
+          <a:effectLst/>
+        </p:spPr>
+        <p:style>
+          <a:lnRef idx="1">
+            <a:schemeClr val="accent1"/>
+          </a:lnRef>
+          <a:fillRef idx="3">
+            <a:schemeClr val="accent1"/>
+          </a:fillRef>
+          <a:effectRef idx="2">
+            <a:schemeClr val="accent1"/>
+          </a:effectRef>
+          <a:fontRef idx="minor">
+            <a:schemeClr val="lt1"/>
+          </a:fontRef>
+        </p:style>
+        <p:txBody>
+          <a:bodyPr rtlCol="0" anchor="ctr"/>
+          <a:lstStyle/>
+          <a:p>
+            <a:pPr algn="ctr"/>
+          </a:p>
+        </p:txBody>
+      </p:sp>
+      <p:sp>
+        <p:nvSpPr>
+          <p:cNvPr id="8" name="Rectangle 7"/>
+          <p:cNvSpPr/>
+          <p:nvPr/>
+        </p:nvSpPr>
+        <p:spPr>
+          <a:xfrm>
+            <a:off x="566928" y="5440679"/>
+            <a:ext cx="50292" cy="530352"/>
+          </a:xfrm>
+          <a:prstGeom prst="rect">
+            <a:avLst/>
+          </a:prstGeom>
+          <a:solidFill>
+            <a:srgbClr val="2F5D8A"/>
+          </a:solidFill>
+          <a:ln>
+            <a:noFill/>
+          </a:ln>
+          <a:effectLst/>
+        </p:spPr>
+        <p:style>
+          <a:lnRef idx="1">
+            <a:schemeClr val="accent1"/>
+          </a:lnRef>
+          <a:fillRef idx="3">
+            <a:schemeClr val="accent1"/>
+          </a:fillRef>
+          <a:effectRef idx="2">
+            <a:schemeClr val="accent1"/>
+          </a:effectRef>
+          <a:fontRef idx="minor">
+            <a:schemeClr val="lt1"/>
+          </a:fontRef>
+        </p:style>
+        <p:txBody>
+          <a:bodyPr rtlCol="0" anchor="ctr"/>
+          <a:lstStyle/>
+          <a:p>
+            <a:pPr algn="ctr"/>
+          </a:p>
+        </p:txBody>
+      </p:sp>
+      <p:sp>
+        <p:nvSpPr>
+          <p:cNvPr id="9" name="TextBox 8"/>
+          <p:cNvSpPr txBox="1"/>
+          <p:nvPr/>
+        </p:nvSpPr>
+        <p:spPr>
+          <a:xfrm>
+            <a:off x="786384" y="5440679"/>
+            <a:ext cx="10655503" cy="530352"/>
+          </a:xfrm>
+          <a:prstGeom prst="rect">
+            <a:avLst/>
+          </a:prstGeom>
+          <a:noFill/>
+        </p:spPr>
+        <p:txBody>
+          <a:bodyPr wrap="square" anchor="ctr" lIns="0" rIns="0" tIns="0" bIns="0">
+            <a:spAutoFit/>
+          </a:bodyPr>
+          <a:lstStyle/>
+          <a:p>
+            <a:pPr algn="l">
+              <a:lnSpc>
+                <a:spcPct val="106000"/>
+              </a:lnSpc>
+              <a:spcBef>
+                <a:spcPts val="0"/>
+              </a:spcBef>
+              <a:spcAft>
+                <a:spcPts val="0"/>
+              </a:spcAft>
+            </a:pPr>
+            <a:r>
+              <a:rPr sz="1250" b="0" i="0">
+                <a:solidFill>
+                  <a:srgbClr val="333F4F"/>
+                </a:solidFill>
+                <a:latin typeface="Segoe UI"/>
+              </a:rPr>
+              <a:t>Sonuç: Kazançların tamamı akustik model ve çözümlemeden geldi; tel seçimine bağlam kuralı eklemek çalınan teli her denemede bozdu.</a:t>
+            </a:r>
+          </a:p>
+        </p:txBody>
+      </p:sp>
+      <p:sp>
+        <p:nvSpPr>
+          <p:cNvPr id="10" name="TextBox 9"/>
+          <p:cNvSpPr txBox="1"/>
+          <p:nvPr/>
+        </p:nvSpPr>
+        <p:spPr>
+          <a:xfrm>
+            <a:off x="566928" y="6108192"/>
+            <a:ext cx="11057839" cy="310896"/>
+          </a:xfrm>
+          <a:prstGeom prst="rect">
+            <a:avLst/>
+          </a:prstGeom>
+          <a:noFill/>
+        </p:spPr>
+        <p:txBody>
+          <a:bodyPr wrap="square" anchor="ctr" lIns="0" rIns="0" tIns="0" bIns="0">
+            <a:spAutoFit/>
+          </a:bodyPr>
+          <a:lstStyle/>
+          <a:p>
+            <a:pPr algn="l">
+              <a:lnSpc>
+                <a:spcPct val="105000"/>
+              </a:lnSpc>
+              <a:spcBef>
+                <a:spcPts val="0"/>
+              </a:spcBef>
+              <a:spcAft>
+                <a:spcPts val="0"/>
+              </a:spcAft>
+            </a:pPr>
+            <a:r>
+              <a:rPr sz="900" b="0" i="0">
+                <a:solidFill>
+                  <a:srgbClr val="5A6472"/>
+                </a:solidFill>
+                <a:latin typeface="Segoe UI"/>
+              </a:rPr>
+              <a:t>Ayrıntı: docs/PROJE_RAPORU.md §4 ve §6; devlog README7, 9–14, 18, 22, 23</a:t>
+            </a:r>
+          </a:p>
+        </p:txBody>
+      </p:sp>
+    </p:spTree>
+  </p:cSld>
+  <p:clrMapOvr>
+    <a:masterClrMapping/>
+  </p:clrMapOvr>
+</p:sld>
+</file>
+
+<file path=ppt/slides/slide18.xml><?xml version="1.0" encoding="utf-8"?>
+<p:sld xmlns:a="http://schemas.openxmlformats.org/drawingml/2006/main" xmlns:p="http://schemas.openxmlformats.org/presentationml/2006/main" xmlns:r="http://schemas.openxmlformats.org/officeDocument/2006/relationships">
+  <p:cSld>
+    <p:spTree>
+      <p:nvGrpSpPr>
+        <p:cNvPr id="1" name=""/>
+        <p:cNvGrpSpPr/>
+        <p:nvPr/>
+      </p:nvGrpSpPr>
+      <p:grpSpPr/>
+      <p:sp>
+        <p:nvSpPr>
+          <p:cNvPr id="2" name="Rectangle 1"/>
+          <p:cNvSpPr/>
+          <p:nvPr/>
+        </p:nvSpPr>
+        <p:spPr>
+          <a:xfrm>
+            <a:off x="566928" y="365760"/>
+            <a:ext cx="566928" cy="566928"/>
+          </a:xfrm>
+          <a:prstGeom prst="rect">
+            <a:avLst/>
+          </a:prstGeom>
+          <a:solidFill>
+            <a:srgbClr val="2F5D8A"/>
+          </a:solidFill>
+          <a:ln>
+            <a:noFill/>
+          </a:ln>
+          <a:effectLst/>
+        </p:spPr>
+        <p:style>
+          <a:lnRef idx="1">
+            <a:schemeClr val="accent1"/>
+          </a:lnRef>
+          <a:fillRef idx="3">
+            <a:schemeClr val="accent1"/>
+          </a:fillRef>
+          <a:effectRef idx="2">
+            <a:schemeClr val="accent1"/>
+          </a:effectRef>
+          <a:fontRef idx="minor">
+            <a:schemeClr val="lt1"/>
+          </a:fontRef>
+        </p:style>
+        <p:txBody>
+          <a:bodyPr rtlCol="0" anchor="ctr"/>
+          <a:lstStyle/>
+          <a:p>
+            <a:pPr algn="ctr"/>
+          </a:p>
+        </p:txBody>
+      </p:sp>
+      <p:sp>
+        <p:nvSpPr>
+          <p:cNvPr id="3" name="TextBox 2"/>
+          <p:cNvSpPr txBox="1"/>
+          <p:nvPr/>
+        </p:nvSpPr>
+        <p:spPr>
+          <a:xfrm>
+            <a:off x="566928" y="365760"/>
+            <a:ext cx="566928" cy="566928"/>
+          </a:xfrm>
+          <a:prstGeom prst="rect">
+            <a:avLst/>
+          </a:prstGeom>
+          <a:noFill/>
+        </p:spPr>
+        <p:txBody>
+          <a:bodyPr wrap="square" anchor="ctr" lIns="0" rIns="0" tIns="0" bIns="0">
+            <a:spAutoFit/>
+          </a:bodyPr>
+          <a:lstStyle/>
+          <a:p>
+            <a:pPr algn="ctr">
+              <a:spcBef>
+                <a:spcPts val="0"/>
+              </a:spcBef>
+              <a:spcAft>
+                <a:spcPts val="0"/>
+              </a:spcAft>
+            </a:pPr>
+            <a:r>
+              <a:rPr sz="2000" b="1" i="0">
+                <a:solidFill>
+                  <a:srgbClr val="FFFFFF"/>
+                </a:solidFill>
+                <a:latin typeface="Segoe UI"/>
+              </a:rPr>
+              <a:t>16</a:t>
+            </a:r>
+          </a:p>
+        </p:txBody>
+      </p:sp>
+      <p:sp>
+        <p:nvSpPr>
+          <p:cNvPr id="4" name="TextBox 3"/>
+          <p:cNvSpPr txBox="1"/>
+          <p:nvPr/>
+        </p:nvSpPr>
+        <p:spPr>
+          <a:xfrm>
+            <a:off x="1280160" y="329184"/>
+            <a:ext cx="10344607" cy="658368"/>
+          </a:xfrm>
+          <a:prstGeom prst="rect">
+            <a:avLst/>
+          </a:prstGeom>
+          <a:noFill/>
+        </p:spPr>
+        <p:txBody>
+          <a:bodyPr wrap="square" anchor="ctr" lIns="0" rIns="0" tIns="0" bIns="0">
+            <a:spAutoFit/>
+          </a:bodyPr>
+          <a:lstStyle/>
+          <a:p>
+            <a:pPr algn="l">
+              <a:lnSpc>
+                <a:spcPct val="100000"/>
+              </a:lnSpc>
+              <a:spcBef>
+                <a:spcPts val="0"/>
+              </a:spcBef>
+              <a:spcAft>
+                <a:spcPts val="200"/>
+              </a:spcAft>
+            </a:pPr>
+            <a:r>
+              <a:rPr sz="2400" b="1" i="0">
+                <a:solidFill>
+                  <a:srgbClr val="17365D"/>
+                </a:solidFill>
+                <a:latin typeface="Segoe UI"/>
+              </a:rPr>
+              <a:t>Açık Sorunlar ve Sıradaki Adımlar</a:t>
+            </a:r>
+          </a:p>
+          <a:p>
+            <a:pPr algn="l">
+              <a:lnSpc>
+                <a:spcPct val="100000"/>
+              </a:lnSpc>
+              <a:spcBef>
+                <a:spcPts val="0"/>
+              </a:spcBef>
+              <a:spcAft>
+                <a:spcPts val="0"/>
+              </a:spcAft>
+            </a:pPr>
+            <a:r>
+              <a:rPr sz="1200" b="0" i="1">
+                <a:solidFill>
+                  <a:srgbClr val="5A6472"/>
+                </a:solidFill>
+                <a:latin typeface="Segoe UI"/>
+              </a:rPr>
+              <a:t>26 Ekim 2026 itibarıyla; bu notlardaki işlerin hiçbiri ürünün doğruluğunu değiştirmedi</a:t>
+            </a:r>
+          </a:p>
+        </p:txBody>
+      </p:sp>
+      <p:sp>
+        <p:nvSpPr>
+          <p:cNvPr id="5" name="Rectangle 4"/>
+          <p:cNvSpPr/>
+          <p:nvPr/>
+        </p:nvSpPr>
+        <p:spPr>
+          <a:xfrm>
+            <a:off x="566928" y="1152144"/>
+            <a:ext cx="11057839" cy="12801"/>
+          </a:xfrm>
+          <a:prstGeom prst="rect">
+            <a:avLst/>
+          </a:prstGeom>
+          <a:solidFill>
+            <a:srgbClr val="D5DEE8"/>
+          </a:solidFill>
+          <a:ln>
+            <a:noFill/>
+          </a:ln>
+          <a:effectLst/>
+        </p:spPr>
+        <p:style>
+          <a:lnRef idx="1">
+            <a:schemeClr val="accent1"/>
+          </a:lnRef>
+          <a:fillRef idx="3">
+            <a:schemeClr val="accent1"/>
+          </a:fillRef>
+          <a:effectRef idx="2">
+            <a:schemeClr val="accent1"/>
+          </a:effectRef>
+          <a:fontRef idx="minor">
+            <a:schemeClr val="lt1"/>
+          </a:fontRef>
+        </p:style>
+        <p:txBody>
+          <a:bodyPr rtlCol="0" anchor="ctr"/>
+          <a:lstStyle/>
+          <a:p>
+            <a:pPr algn="ctr"/>
+          </a:p>
+        </p:txBody>
+      </p:sp>
+      <p:sp>
+        <p:nvSpPr>
+          <p:cNvPr id="6" name="Rectangle 5"/>
+          <p:cNvSpPr/>
+          <p:nvPr/>
+        </p:nvSpPr>
+        <p:spPr>
+          <a:xfrm>
+            <a:off x="566928" y="1444752"/>
+            <a:ext cx="5455767" cy="1249679"/>
+          </a:xfrm>
+          <a:prstGeom prst="rect">
+            <a:avLst/>
+          </a:prstGeom>
+          <a:solidFill>
+            <a:srgbClr val="F1F5FA"/>
+          </a:solidFill>
+          <a:ln>
+            <a:noFill/>
+          </a:ln>
+          <a:effectLst/>
+        </p:spPr>
+        <p:style>
+          <a:lnRef idx="1">
+            <a:schemeClr val="accent1"/>
+          </a:lnRef>
+          <a:fillRef idx="3">
+            <a:schemeClr val="accent1"/>
+          </a:fillRef>
+          <a:effectRef idx="2">
+            <a:schemeClr val="accent1"/>
+          </a:effectRef>
+          <a:fontRef idx="minor">
+            <a:schemeClr val="lt1"/>
+          </a:fontRef>
+        </p:style>
+        <p:txBody>
+          <a:bodyPr rtlCol="0" anchor="ctr"/>
+          <a:lstStyle/>
+          <a:p>
+            <a:pPr algn="ctr"/>
+          </a:p>
+        </p:txBody>
+      </p:sp>
+      <p:sp>
+        <p:nvSpPr>
+          <p:cNvPr id="7" name="Rectangle 6"/>
+          <p:cNvSpPr/>
+          <p:nvPr/>
+        </p:nvSpPr>
+        <p:spPr>
+          <a:xfrm>
+            <a:off x="566928" y="1444752"/>
+            <a:ext cx="41148" cy="1249679"/>
+          </a:xfrm>
+          <a:prstGeom prst="rect">
+            <a:avLst/>
+          </a:prstGeom>
+          <a:solidFill>
+            <a:srgbClr val="2F5D8A"/>
+          </a:solidFill>
+          <a:ln>
+            <a:noFill/>
+          </a:ln>
+          <a:effectLst/>
+        </p:spPr>
+        <p:style>
+          <a:lnRef idx="1">
+            <a:schemeClr val="accent1"/>
+          </a:lnRef>
+          <a:fillRef idx="3">
+            <a:schemeClr val="accent1"/>
+          </a:fillRef>
+          <a:effectRef idx="2">
+            <a:schemeClr val="accent1"/>
+          </a:effectRef>
+          <a:fontRef idx="minor">
+            <a:schemeClr val="lt1"/>
+          </a:fontRef>
+        </p:style>
+        <p:txBody>
+          <a:bodyPr rtlCol="0" anchor="ctr"/>
+          <a:lstStyle/>
+          <a:p>
+            <a:pPr algn="ctr"/>
+          </a:p>
+        </p:txBody>
+      </p:sp>
+      <p:sp>
+        <p:nvSpPr>
+          <p:cNvPr id="8" name="TextBox 7"/>
+          <p:cNvSpPr txBox="1"/>
+          <p:nvPr/>
+        </p:nvSpPr>
+        <p:spPr>
+          <a:xfrm>
+            <a:off x="749808" y="1517904"/>
+            <a:ext cx="5126583" cy="1103376"/>
+          </a:xfrm>
+          <a:prstGeom prst="rect">
+            <a:avLst/>
+          </a:prstGeom>
+          <a:noFill/>
+        </p:spPr>
+        <p:txBody>
+          <a:bodyPr wrap="square" anchor="ctr" lIns="0" rIns="0" tIns="0" bIns="0">
+            <a:spAutoFit/>
+          </a:bodyPr>
+          <a:lstStyle/>
+          <a:p>
+            <a:pPr algn="l">
+              <a:lnSpc>
+                <a:spcPct val="100000"/>
+              </a:lnSpc>
+              <a:spcBef>
+                <a:spcPts val="0"/>
+              </a:spcBef>
+              <a:spcAft>
+                <a:spcPts val="300"/>
+              </a:spcAft>
+            </a:pPr>
+            <a:r>
+              <a:rPr sz="1350" b="1" i="0">
+                <a:solidFill>
+                  <a:srgbClr val="2F5D8A"/>
+                </a:solidFill>
+                <a:latin typeface="Segoe UI"/>
+              </a:rPr>
+              <a:t>Teli sesten ayırmak</a:t>
+            </a:r>
+          </a:p>
+          <a:p>
+            <a:pPr algn="l">
+              <a:lnSpc>
+                <a:spcPct val="106000"/>
+              </a:lnSpc>
+              <a:spcBef>
+                <a:spcPts val="0"/>
+              </a:spcBef>
+              <a:spcAft>
+                <a:spcPts val="0"/>
+              </a:spcAft>
+            </a:pPr>
+            <a:r>
+              <a:rPr sz="1250" b="0" i="0">
+                <a:solidFill>
+                  <a:srgbClr val="333F4F"/>
+                </a:solidFill>
+                <a:latin typeface="Segoe UI"/>
+              </a:rPr>
+              <a:t>Klasik gitarda çalınan tel şans düzeyinde (T02 %36). Sıradaki: modelden bağımsız spektral analiz; olmazsa tel için edisyon modu.</a:t>
+            </a:r>
+          </a:p>
+        </p:txBody>
+      </p:sp>
+      <p:sp>
+        <p:nvSpPr>
+          <p:cNvPr id="9" name="Rectangle 8"/>
+          <p:cNvSpPr/>
+          <p:nvPr/>
+        </p:nvSpPr>
+        <p:spPr>
+          <a:xfrm>
+            <a:off x="6168999" y="1444752"/>
+            <a:ext cx="5455767" cy="1249679"/>
+          </a:xfrm>
+          <a:prstGeom prst="rect">
+            <a:avLst/>
+          </a:prstGeom>
+          <a:solidFill>
+            <a:srgbClr val="F1F5FA"/>
+          </a:solidFill>
+          <a:ln>
+            <a:noFill/>
+          </a:ln>
+          <a:effectLst/>
+        </p:spPr>
+        <p:style>
+          <a:lnRef idx="1">
+            <a:schemeClr val="accent1"/>
+          </a:lnRef>
+          <a:fillRef idx="3">
+            <a:schemeClr val="accent1"/>
+          </a:fillRef>
+          <a:effectRef idx="2">
+            <a:schemeClr val="accent1"/>
+          </a:effectRef>
+          <a:fontRef idx="minor">
+            <a:schemeClr val="lt1"/>
+          </a:fontRef>
+        </p:style>
+        <p:txBody>
+          <a:bodyPr rtlCol="0" anchor="ctr"/>
+          <a:lstStyle/>
+          <a:p>
+            <a:pPr algn="ctr"/>
+          </a:p>
+        </p:txBody>
+      </p:sp>
+      <p:sp>
+        <p:nvSpPr>
+          <p:cNvPr id="10" name="Rectangle 9"/>
+          <p:cNvSpPr/>
+          <p:nvPr/>
+        </p:nvSpPr>
+        <p:spPr>
+          <a:xfrm>
+            <a:off x="6168999" y="1444752"/>
+            <a:ext cx="41148" cy="1249679"/>
+          </a:xfrm>
+          <a:prstGeom prst="rect">
+            <a:avLst/>
+          </a:prstGeom>
+          <a:solidFill>
+            <a:srgbClr val="2F5D8A"/>
+          </a:solidFill>
+          <a:ln>
+            <a:noFill/>
+          </a:ln>
+          <a:effectLst/>
+        </p:spPr>
+        <p:style>
+          <a:lnRef idx="1">
+            <a:schemeClr val="accent1"/>
+          </a:lnRef>
+          <a:fillRef idx="3">
+            <a:schemeClr val="accent1"/>
+          </a:fillRef>
+          <a:effectRef idx="2">
+            <a:schemeClr val="accent1"/>
+          </a:effectRef>
+          <a:fontRef idx="minor">
+            <a:schemeClr val="lt1"/>
+          </a:fontRef>
+        </p:style>
+        <p:txBody>
+          <a:bodyPr rtlCol="0" anchor="ctr"/>
+          <a:lstStyle/>
+          <a:p>
+            <a:pPr algn="ctr"/>
+          </a:p>
+        </p:txBody>
+      </p:sp>
+      <p:sp>
+        <p:nvSpPr>
+          <p:cNvPr id="11" name="TextBox 10"/>
+          <p:cNvSpPr txBox="1"/>
+          <p:nvPr/>
+        </p:nvSpPr>
+        <p:spPr>
+          <a:xfrm>
+            <a:off x="6351879" y="1517904"/>
+            <a:ext cx="5126583" cy="1103376"/>
+          </a:xfrm>
+          <a:prstGeom prst="rect">
+            <a:avLst/>
+          </a:prstGeom>
+          <a:noFill/>
+        </p:spPr>
+        <p:txBody>
+          <a:bodyPr wrap="square" anchor="ctr" lIns="0" rIns="0" tIns="0" bIns="0">
+            <a:spAutoFit/>
+          </a:bodyPr>
+          <a:lstStyle/>
+          <a:p>
+            <a:pPr algn="l">
+              <a:lnSpc>
+                <a:spcPct val="100000"/>
+              </a:lnSpc>
+              <a:spcBef>
+                <a:spcPts val="0"/>
+              </a:spcBef>
+              <a:spcAft>
+                <a:spcPts val="300"/>
+              </a:spcAft>
+            </a:pPr>
+            <a:r>
+              <a:rPr sz="1350" b="1" i="0">
+                <a:solidFill>
+                  <a:srgbClr val="2F5D8A"/>
+                </a:solidFill>
+                <a:latin typeface="Segoe UI"/>
+              </a:rPr>
+              <a:t>Akustik model kararı</a:t>
+            </a:r>
+          </a:p>
+          <a:p>
+            <a:pPr algn="l">
+              <a:lnSpc>
+                <a:spcPct val="106000"/>
+              </a:lnSpc>
+              <a:spcBef>
+                <a:spcPts val="0"/>
+              </a:spcBef>
+              <a:spcAft>
+                <a:spcPts val="0"/>
+              </a:spcAft>
+            </a:pPr>
+            <a:r>
+              <a:rPr sz="1250" b="0" i="0">
+                <a:solidFill>
+                  <a:srgbClr val="333F4F"/>
+                </a:solidFill>
+                <a:latin typeface="Segoe UI"/>
+              </a:rPr>
+              <a:t>Kontrol modeli (test nota F1 0,824) ve tını çeşitlendirmeli model aday; önce vuruş ağı yeniden eğitilip GuitarSet kontrol edilecek.</a:t>
+            </a:r>
+          </a:p>
+        </p:txBody>
+      </p:sp>
+      <p:sp>
+        <p:nvSpPr>
+          <p:cNvPr id="12" name="Rectangle 11"/>
+          <p:cNvSpPr/>
+          <p:nvPr/>
+        </p:nvSpPr>
+        <p:spPr>
+          <a:xfrm>
+            <a:off x="566928" y="2840736"/>
+            <a:ext cx="5455767" cy="1249679"/>
+          </a:xfrm>
+          <a:prstGeom prst="rect">
+            <a:avLst/>
+          </a:prstGeom>
+          <a:solidFill>
+            <a:srgbClr val="F1F5FA"/>
+          </a:solidFill>
+          <a:ln>
+            <a:noFill/>
+          </a:ln>
+          <a:effectLst/>
+        </p:spPr>
+        <p:style>
+          <a:lnRef idx="1">
+            <a:schemeClr val="accent1"/>
+          </a:lnRef>
+          <a:fillRef idx="3">
+            <a:schemeClr val="accent1"/>
+          </a:fillRef>
+          <a:effectRef idx="2">
+            <a:schemeClr val="accent1"/>
+          </a:effectRef>
+          <a:fontRef idx="minor">
+            <a:schemeClr val="lt1"/>
+          </a:fontRef>
+        </p:style>
+        <p:txBody>
+          <a:bodyPr rtlCol="0" anchor="ctr"/>
+          <a:lstStyle/>
+          <a:p>
+            <a:pPr algn="ctr"/>
+          </a:p>
+        </p:txBody>
+      </p:sp>
+      <p:sp>
+        <p:nvSpPr>
+          <p:cNvPr id="13" name="Rectangle 12"/>
+          <p:cNvSpPr/>
+          <p:nvPr/>
+        </p:nvSpPr>
+        <p:spPr>
+          <a:xfrm>
+            <a:off x="566928" y="2840736"/>
+            <a:ext cx="41148" cy="1249679"/>
+          </a:xfrm>
+          <a:prstGeom prst="rect">
+            <a:avLst/>
+          </a:prstGeom>
+          <a:solidFill>
+            <a:srgbClr val="2F5D8A"/>
+          </a:solidFill>
+          <a:ln>
+            <a:noFill/>
+          </a:ln>
+          <a:effectLst/>
+        </p:spPr>
+        <p:style>
+          <a:lnRef idx="1">
+            <a:schemeClr val="accent1"/>
+          </a:lnRef>
+          <a:fillRef idx="3">
+            <a:schemeClr val="accent1"/>
+          </a:fillRef>
+          <a:effectRef idx="2">
+            <a:schemeClr val="accent1"/>
+          </a:effectRef>
+          <a:fontRef idx="minor">
+            <a:schemeClr val="lt1"/>
+          </a:fontRef>
+        </p:style>
+        <p:txBody>
+          <a:bodyPr rtlCol="0" anchor="ctr"/>
+          <a:lstStyle/>
+          <a:p>
+            <a:pPr algn="ctr"/>
+          </a:p>
+        </p:txBody>
+      </p:sp>
+      <p:sp>
+        <p:nvSpPr>
+          <p:cNvPr id="14" name="TextBox 13"/>
+          <p:cNvSpPr txBox="1"/>
+          <p:nvPr/>
+        </p:nvSpPr>
+        <p:spPr>
+          <a:xfrm>
+            <a:off x="749808" y="2913888"/>
+            <a:ext cx="5126583" cy="1103376"/>
+          </a:xfrm>
+          <a:prstGeom prst="rect">
+            <a:avLst/>
+          </a:prstGeom>
+          <a:noFill/>
+        </p:spPr>
+        <p:txBody>
+          <a:bodyPr wrap="square" anchor="ctr" lIns="0" rIns="0" tIns="0" bIns="0">
+            <a:spAutoFit/>
+          </a:bodyPr>
+          <a:lstStyle/>
+          <a:p>
+            <a:pPr algn="l">
+              <a:lnSpc>
+                <a:spcPct val="100000"/>
+              </a:lnSpc>
+              <a:spcBef>
+                <a:spcPts val="0"/>
+              </a:spcBef>
+              <a:spcAft>
+                <a:spcPts val="300"/>
+              </a:spcAft>
+            </a:pPr>
+            <a:r>
+              <a:rPr sz="1350" b="1" i="0">
+                <a:solidFill>
+                  <a:srgbClr val="2F5D8A"/>
+                </a:solidFill>
+                <a:latin typeface="Segoe UI"/>
+              </a:rPr>
+              <a:t>Vuruş takibi</a:t>
+            </a:r>
+          </a:p>
+          <a:p>
+            <a:pPr algn="l">
+              <a:lnSpc>
+                <a:spcPct val="106000"/>
+              </a:lnSpc>
+              <a:spcBef>
+                <a:spcPts val="0"/>
+              </a:spcBef>
+              <a:spcAft>
+                <a:spcPts val="0"/>
+              </a:spcAft>
+            </a:pPr>
+            <a:r>
+              <a:rPr sz="1250" b="0" i="0">
+                <a:solidFill>
+                  <a:srgbClr val="333F4F"/>
+                </a:solidFill>
+                <a:latin typeface="Segoe UI"/>
+              </a:rPr>
+              <a:t>Yarı otomatik uçtan uca IOI 0,695; tap modu simülasyonda 0,877. Gerçek dokunuşla doğrulama bekliyor.</a:t>
+            </a:r>
+          </a:p>
+        </p:txBody>
+      </p:sp>
+      <p:sp>
+        <p:nvSpPr>
+          <p:cNvPr id="15" name="Rectangle 14"/>
+          <p:cNvSpPr/>
+          <p:nvPr/>
+        </p:nvSpPr>
+        <p:spPr>
+          <a:xfrm>
+            <a:off x="6168999" y="2840736"/>
+            <a:ext cx="5455767" cy="1249679"/>
+          </a:xfrm>
+          <a:prstGeom prst="rect">
+            <a:avLst/>
+          </a:prstGeom>
+          <a:solidFill>
+            <a:srgbClr val="F1F5FA"/>
+          </a:solidFill>
+          <a:ln>
+            <a:noFill/>
+          </a:ln>
+          <a:effectLst/>
+        </p:spPr>
+        <p:style>
+          <a:lnRef idx="1">
+            <a:schemeClr val="accent1"/>
+          </a:lnRef>
+          <a:fillRef idx="3">
+            <a:schemeClr val="accent1"/>
+          </a:fillRef>
+          <a:effectRef idx="2">
+            <a:schemeClr val="accent1"/>
+          </a:effectRef>
+          <a:fontRef idx="minor">
+            <a:schemeClr val="lt1"/>
+          </a:fontRef>
+        </p:style>
+        <p:txBody>
+          <a:bodyPr rtlCol="0" anchor="ctr"/>
+          <a:lstStyle/>
+          <a:p>
+            <a:pPr algn="ctr"/>
+          </a:p>
+        </p:txBody>
+      </p:sp>
+      <p:sp>
+        <p:nvSpPr>
+          <p:cNvPr id="16" name="Rectangle 15"/>
+          <p:cNvSpPr/>
+          <p:nvPr/>
+        </p:nvSpPr>
+        <p:spPr>
+          <a:xfrm>
+            <a:off x="6168999" y="2840736"/>
+            <a:ext cx="41148" cy="1249679"/>
+          </a:xfrm>
+          <a:prstGeom prst="rect">
+            <a:avLst/>
+          </a:prstGeom>
+          <a:solidFill>
+            <a:srgbClr val="2F5D8A"/>
+          </a:solidFill>
+          <a:ln>
+            <a:noFill/>
+          </a:ln>
+          <a:effectLst/>
+        </p:spPr>
+        <p:style>
+          <a:lnRef idx="1">
+            <a:schemeClr val="accent1"/>
+          </a:lnRef>
+          <a:fillRef idx="3">
+            <a:schemeClr val="accent1"/>
+          </a:fillRef>
+          <a:effectRef idx="2">
+            <a:schemeClr val="accent1"/>
+          </a:effectRef>
+          <a:fontRef idx="minor">
+            <a:schemeClr val="lt1"/>
+          </a:fontRef>
+        </p:style>
+        <p:txBody>
+          <a:bodyPr rtlCol="0" anchor="ctr"/>
+          <a:lstStyle/>
+          <a:p>
+            <a:pPr algn="ctr"/>
+          </a:p>
+        </p:txBody>
+      </p:sp>
+      <p:sp>
+        <p:nvSpPr>
+          <p:cNvPr id="17" name="TextBox 16"/>
+          <p:cNvSpPr txBox="1"/>
+          <p:nvPr/>
+        </p:nvSpPr>
+        <p:spPr>
+          <a:xfrm>
+            <a:off x="6351879" y="2913888"/>
+            <a:ext cx="5126583" cy="1103376"/>
+          </a:xfrm>
+          <a:prstGeom prst="rect">
+            <a:avLst/>
+          </a:prstGeom>
+          <a:noFill/>
+        </p:spPr>
+        <p:txBody>
+          <a:bodyPr wrap="square" anchor="ctr" lIns="0" rIns="0" tIns="0" bIns="0">
+            <a:spAutoFit/>
+          </a:bodyPr>
+          <a:lstStyle/>
+          <a:p>
+            <a:pPr algn="l">
+              <a:lnSpc>
+                <a:spcPct val="100000"/>
+              </a:lnSpc>
+              <a:spcBef>
+                <a:spcPts val="0"/>
+              </a:spcBef>
+              <a:spcAft>
+                <a:spcPts val="300"/>
+              </a:spcAft>
+            </a:pPr>
+            <a:r>
+              <a:rPr sz="1350" b="1" i="0">
+                <a:solidFill>
+                  <a:srgbClr val="2F5D8A"/>
+                </a:solidFill>
+                <a:latin typeface="Segoe UI"/>
+              </a:rPr>
+              <a:t>Hayalet notalar</a:t>
+            </a:r>
+          </a:p>
+          <a:p>
+            <a:pPr algn="l">
+              <a:lnSpc>
+                <a:spcPct val="106000"/>
+              </a:lnSpc>
+              <a:spcBef>
+                <a:spcPts val="0"/>
+              </a:spcBef>
+              <a:spcAft>
+                <a:spcPts val="0"/>
+              </a:spcAft>
+            </a:pPr>
+            <a:r>
+              <a:rPr sz="1250" b="0" i="0">
+                <a:solidFill>
+                  <a:srgbClr val="333F4F"/>
+                </a:solidFill>
+                <a:latin typeface="Segoe UI"/>
+              </a:rPr>
+              <a:t>Parça %31, üst ses %25, açık tel %11 ve &lt;100 ms aynı perde tekrarları: kuralla ayrılmıyor, model düzeyinde iş.</a:t>
+            </a:r>
+          </a:p>
+        </p:txBody>
+      </p:sp>
+      <p:sp>
+        <p:nvSpPr>
+          <p:cNvPr id="18" name="Rectangle 17"/>
+          <p:cNvSpPr/>
+          <p:nvPr/>
+        </p:nvSpPr>
+        <p:spPr>
+          <a:xfrm>
+            <a:off x="566928" y="4236720"/>
+            <a:ext cx="5455767" cy="1249679"/>
+          </a:xfrm>
+          <a:prstGeom prst="rect">
+            <a:avLst/>
+          </a:prstGeom>
+          <a:solidFill>
+            <a:srgbClr val="F1F5FA"/>
+          </a:solidFill>
+          <a:ln>
+            <a:noFill/>
+          </a:ln>
+          <a:effectLst/>
+        </p:spPr>
+        <p:style>
+          <a:lnRef idx="1">
+            <a:schemeClr val="accent1"/>
+          </a:lnRef>
+          <a:fillRef idx="3">
+            <a:schemeClr val="accent1"/>
+          </a:fillRef>
+          <a:effectRef idx="2">
+            <a:schemeClr val="accent1"/>
+          </a:effectRef>
+          <a:fontRef idx="minor">
+            <a:schemeClr val="lt1"/>
+          </a:fontRef>
+        </p:style>
+        <p:txBody>
+          <a:bodyPr rtlCol="0" anchor="ctr"/>
+          <a:lstStyle/>
+          <a:p>
+            <a:pPr algn="ctr"/>
+          </a:p>
+        </p:txBody>
+      </p:sp>
+      <p:sp>
+        <p:nvSpPr>
+          <p:cNvPr id="19" name="Rectangle 18"/>
+          <p:cNvSpPr/>
+          <p:nvPr/>
+        </p:nvSpPr>
+        <p:spPr>
+          <a:xfrm>
+            <a:off x="566928" y="4236720"/>
+            <a:ext cx="41148" cy="1249679"/>
+          </a:xfrm>
+          <a:prstGeom prst="rect">
+            <a:avLst/>
+          </a:prstGeom>
+          <a:solidFill>
+            <a:srgbClr val="2F5D8A"/>
+          </a:solidFill>
+          <a:ln>
+            <a:noFill/>
+          </a:ln>
+          <a:effectLst/>
+        </p:spPr>
+        <p:style>
+          <a:lnRef idx="1">
+            <a:schemeClr val="accent1"/>
+          </a:lnRef>
+          <a:fillRef idx="3">
+            <a:schemeClr val="accent1"/>
+          </a:fillRef>
+          <a:effectRef idx="2">
+            <a:schemeClr val="accent1"/>
+          </a:effectRef>
+          <a:fontRef idx="minor">
+            <a:schemeClr val="lt1"/>
+          </a:fontRef>
+        </p:style>
+        <p:txBody>
+          <a:bodyPr rtlCol="0" anchor="ctr"/>
+          <a:lstStyle/>
+          <a:p>
+            <a:pPr algn="ctr"/>
+          </a:p>
+        </p:txBody>
+      </p:sp>
+      <p:sp>
+        <p:nvSpPr>
+          <p:cNvPr id="20" name="TextBox 19"/>
+          <p:cNvSpPr txBox="1"/>
+          <p:nvPr/>
+        </p:nvSpPr>
+        <p:spPr>
+          <a:xfrm>
+            <a:off x="749808" y="4309872"/>
+            <a:ext cx="5126583" cy="1103376"/>
+          </a:xfrm>
+          <a:prstGeom prst="rect">
+            <a:avLst/>
+          </a:prstGeom>
+          <a:noFill/>
+        </p:spPr>
+        <p:txBody>
+          <a:bodyPr wrap="square" anchor="ctr" lIns="0" rIns="0" tIns="0" bIns="0">
+            <a:spAutoFit/>
+          </a:bodyPr>
+          <a:lstStyle/>
+          <a:p>
+            <a:pPr algn="l">
+              <a:lnSpc>
+                <a:spcPct val="100000"/>
+              </a:lnSpc>
+              <a:spcBef>
+                <a:spcPts val="0"/>
+              </a:spcBef>
+              <a:spcAft>
+                <a:spcPts val="300"/>
+              </a:spcAft>
+            </a:pPr>
+            <a:r>
+              <a:rPr sz="1350" b="1" i="0">
+                <a:solidFill>
+                  <a:srgbClr val="2F5D8A"/>
+                </a:solidFill>
+                <a:latin typeface="Segoe UI"/>
+              </a:rPr>
+              <a:t>Guitar Pro (.gp) çıktısı</a:t>
+            </a:r>
+          </a:p>
+          <a:p>
+            <a:pPr algn="l">
+              <a:lnSpc>
+                <a:spcPct val="106000"/>
+              </a:lnSpc>
+              <a:spcBef>
+                <a:spcPts val="0"/>
+              </a:spcBef>
+              <a:spcAft>
+                <a:spcPts val="0"/>
+              </a:spcAft>
+            </a:pPr>
+            <a:r>
+              <a:rPr sz="1250" b="0" i="0">
+                <a:solidFill>
+                  <a:srgbClr val="333F4F"/>
+                </a:solidFill>
+                <a:latin typeface="Segoe UI"/>
+              </a:rPr>
+              <a:t>Naylon gitar kanalı ve ölçü senkronu çalışıyor; gömülü ses henüz yüklenmiyor. Vuruş başına senkronla notaların %95'i ≤ 100 ms.</a:t>
+            </a:r>
+          </a:p>
+        </p:txBody>
+      </p:sp>
+      <p:sp>
+        <p:nvSpPr>
+          <p:cNvPr id="21" name="Rectangle 20"/>
+          <p:cNvSpPr/>
+          <p:nvPr/>
+        </p:nvSpPr>
+        <p:spPr>
+          <a:xfrm>
+            <a:off x="6168999" y="4236720"/>
+            <a:ext cx="5455767" cy="1249679"/>
+          </a:xfrm>
+          <a:prstGeom prst="rect">
+            <a:avLst/>
+          </a:prstGeom>
+          <a:solidFill>
+            <a:srgbClr val="F1F5FA"/>
+          </a:solidFill>
+          <a:ln>
+            <a:noFill/>
+          </a:ln>
+          <a:effectLst/>
+        </p:spPr>
+        <p:style>
+          <a:lnRef idx="1">
+            <a:schemeClr val="accent1"/>
+          </a:lnRef>
+          <a:fillRef idx="3">
+            <a:schemeClr val="accent1"/>
+          </a:fillRef>
+          <a:effectRef idx="2">
+            <a:schemeClr val="accent1"/>
+          </a:effectRef>
+          <a:fontRef idx="minor">
+            <a:schemeClr val="lt1"/>
+          </a:fontRef>
+        </p:style>
+        <p:txBody>
+          <a:bodyPr rtlCol="0" anchor="ctr"/>
+          <a:lstStyle/>
+          <a:p>
+            <a:pPr algn="ctr"/>
+          </a:p>
+        </p:txBody>
+      </p:sp>
+      <p:sp>
+        <p:nvSpPr>
+          <p:cNvPr id="22" name="Rectangle 21"/>
+          <p:cNvSpPr/>
+          <p:nvPr/>
+        </p:nvSpPr>
+        <p:spPr>
+          <a:xfrm>
+            <a:off x="6168999" y="4236720"/>
+            <a:ext cx="41148" cy="1249679"/>
+          </a:xfrm>
+          <a:prstGeom prst="rect">
+            <a:avLst/>
+          </a:prstGeom>
+          <a:solidFill>
+            <a:srgbClr val="2F5D8A"/>
+          </a:solidFill>
+          <a:ln>
+            <a:noFill/>
+          </a:ln>
+          <a:effectLst/>
+        </p:spPr>
+        <p:style>
+          <a:lnRef idx="1">
+            <a:schemeClr val="accent1"/>
+          </a:lnRef>
+          <a:fillRef idx="3">
+            <a:schemeClr val="accent1"/>
+          </a:fillRef>
+          <a:effectRef idx="2">
+            <a:schemeClr val="accent1"/>
+          </a:effectRef>
+          <a:fontRef idx="minor">
+            <a:schemeClr val="lt1"/>
+          </a:fontRef>
+        </p:style>
+        <p:txBody>
+          <a:bodyPr rtlCol="0" anchor="ctr"/>
+          <a:lstStyle/>
+          <a:p>
+            <a:pPr algn="ctr"/>
+          </a:p>
+        </p:txBody>
+      </p:sp>
+      <p:sp>
+        <p:nvSpPr>
+          <p:cNvPr id="23" name="TextBox 22"/>
+          <p:cNvSpPr txBox="1"/>
+          <p:nvPr/>
+        </p:nvSpPr>
+        <p:spPr>
+          <a:xfrm>
+            <a:off x="6351879" y="4309872"/>
+            <a:ext cx="5126583" cy="1103376"/>
+          </a:xfrm>
+          <a:prstGeom prst="rect">
+            <a:avLst/>
+          </a:prstGeom>
+          <a:noFill/>
+        </p:spPr>
+        <p:txBody>
+          <a:bodyPr wrap="square" anchor="ctr" lIns="0" rIns="0" tIns="0" bIns="0">
+            <a:spAutoFit/>
+          </a:bodyPr>
+          <a:lstStyle/>
+          <a:p>
+            <a:pPr algn="l">
+              <a:lnSpc>
+                <a:spcPct val="100000"/>
+              </a:lnSpc>
+              <a:spcBef>
+                <a:spcPts val="0"/>
+              </a:spcBef>
+              <a:spcAft>
+                <a:spcPts val="300"/>
+              </a:spcAft>
+            </a:pPr>
+            <a:r>
+              <a:rPr sz="1350" b="1" i="0">
+                <a:solidFill>
+                  <a:srgbClr val="2F5D8A"/>
+                </a:solidFill>
+                <a:latin typeface="Segoe UI"/>
+              </a:rPr>
+              <a:t>Doğrulama ve teknikler</a:t>
+            </a:r>
+          </a:p>
+          <a:p>
+            <a:pPr algn="l">
+              <a:lnSpc>
+                <a:spcPct val="106000"/>
+              </a:lnSpc>
+              <a:spcBef>
+                <a:spcPts val="0"/>
+              </a:spcBef>
+              <a:spcAft>
+                <a:spcPts val="0"/>
+              </a:spcAft>
+            </a:pPr>
+            <a:r>
+              <a:rPr sz="1250" b="0" i="0">
+                <a:solidFill>
+                  <a:srgbClr val="333F4F"/>
+                </a:solidFill>
+                <a:latin typeface="Segoe UI"/>
+              </a:rPr>
+              <a:t>İcracıya göre 5 katlı CV, bootstrap güven aralıkları; Katman 4 (bend, slide, legato) kendi teknik verimizle.</a:t>
+            </a:r>
+          </a:p>
+        </p:txBody>
+      </p:sp>
+      <p:sp>
+        <p:nvSpPr>
+          <p:cNvPr id="24" name="TextBox 23"/>
+          <p:cNvSpPr txBox="1"/>
+          <p:nvPr/>
+        </p:nvSpPr>
+        <p:spPr>
+          <a:xfrm>
+            <a:off x="566928" y="5623560"/>
+            <a:ext cx="11057839" cy="237744"/>
+          </a:xfrm>
+          <a:prstGeom prst="rect">
+            <a:avLst/>
+          </a:prstGeom>
+          <a:noFill/>
+        </p:spPr>
+        <p:txBody>
+          <a:bodyPr wrap="square" anchor="ctr" lIns="0" rIns="0" tIns="0" bIns="0">
+            <a:spAutoFit/>
+          </a:bodyPr>
+          <a:lstStyle/>
+          <a:p>
+            <a:pPr algn="ctr">
+              <a:spcBef>
+                <a:spcPts val="0"/>
+              </a:spcBef>
+              <a:spcAft>
+                <a:spcPts val="0"/>
+              </a:spcAft>
+            </a:pPr>
+            <a:r>
+              <a:rPr sz="1000" b="1" i="0">
+                <a:solidFill>
+                  <a:srgbClr val="5A6472"/>
+                </a:solidFill>
+                <a:latin typeface="Segoe UI"/>
+              </a:rPr>
+              <a:t>ZİNCİRİN DURUMU    ✓ çalışıyor    ~ kısmi    ✗ açık</a:t>
+            </a:r>
+          </a:p>
+        </p:txBody>
+      </p:sp>
+      <p:sp>
+        <p:nvSpPr>
+          <p:cNvPr id="25" name="TextBox 24"/>
+          <p:cNvSpPr txBox="1"/>
+          <p:nvPr/>
+        </p:nvSpPr>
+        <p:spPr>
+          <a:xfrm>
+            <a:off x="566928" y="5998464"/>
+            <a:ext cx="11057839" cy="420624"/>
+          </a:xfrm>
+          <a:prstGeom prst="rect">
+            <a:avLst/>
+          </a:prstGeom>
+          <a:noFill/>
+        </p:spPr>
+        <p:txBody>
+          <a:bodyPr wrap="square" anchor="ctr" lIns="0" rIns="0" tIns="0" bIns="0">
+            <a:spAutoFit/>
+          </a:bodyPr>
+          <a:lstStyle/>
+          <a:p>
+            <a:pPr algn="ctr"/>
+            <a:r>
+              <a:rPr sz="1200" b="1">
+                <a:solidFill>
+                  <a:srgbClr val="2F5D8A"/>
+                </a:solidFill>
+                <a:latin typeface="Segoe UI"/>
+              </a:rPr>
+              <a:t>Audio ✓</a:t>
+            </a:r>
+            <a:r>
+              <a:rPr sz="1200" b="1">
+                <a:solidFill>
+                  <a:srgbClr val="B5762A"/>
+                </a:solidFill>
+                <a:latin typeface="Segoe UI"/>
+              </a:rPr>
+              <a:t>   →   </a:t>
+            </a:r>
+            <a:r>
+              <a:rPr sz="1200" b="1">
+                <a:solidFill>
+                  <a:srgbClr val="2F5D8A"/>
+                </a:solidFill>
+                <a:latin typeface="Segoe UI"/>
+              </a:rPr>
+              <a:t>Nota ✓</a:t>
+            </a:r>
+            <a:r>
+              <a:rPr sz="1200" b="1">
+                <a:solidFill>
+                  <a:srgbClr val="B5762A"/>
+                </a:solidFill>
+                <a:latin typeface="Segoe UI"/>
+              </a:rPr>
+              <a:t>   →   </a:t>
+            </a:r>
+            <a:r>
+              <a:rPr sz="1200" b="1">
+                <a:solidFill>
+                  <a:srgbClr val="2F5D8A"/>
+                </a:solidFill>
+                <a:latin typeface="Segoe UI"/>
+              </a:rPr>
+              <a:t>Polifoni ✓</a:t>
+            </a:r>
+            <a:r>
+              <a:rPr sz="1200" b="1">
+                <a:solidFill>
+                  <a:srgbClr val="B5762A"/>
+                </a:solidFill>
+                <a:latin typeface="Segoe UI"/>
+              </a:rPr>
+              <a:t>   →   </a:t>
+            </a:r>
+            <a:r>
+              <a:rPr sz="1200" b="1">
+                <a:solidFill>
+                  <a:srgbClr val="2F5D8A"/>
+                </a:solidFill>
+                <a:latin typeface="Segoe UI"/>
+              </a:rPr>
+              <a:t>Tel (edisyon ✓, ses ✗)</a:t>
+            </a:r>
+            <a:r>
+              <a:rPr sz="1200" b="1">
+                <a:solidFill>
+                  <a:srgbClr val="B5762A"/>
+                </a:solidFill>
+                <a:latin typeface="Segoe UI"/>
+              </a:rPr>
+              <a:t>   →   </a:t>
+            </a:r>
+            <a:r>
+              <a:rPr sz="1200" b="1">
+                <a:solidFill>
+                  <a:srgbClr val="2F5D8A"/>
+                </a:solidFill>
+                <a:latin typeface="Segoe UI"/>
+              </a:rPr>
+              <a:t>Ritim ~</a:t>
+            </a:r>
+            <a:r>
+              <a:rPr sz="1200" b="1">
+                <a:solidFill>
+                  <a:srgbClr val="B5762A"/>
+                </a:solidFill>
+                <a:latin typeface="Segoe UI"/>
+              </a:rPr>
+              <a:t>   →   </a:t>
+            </a:r>
+            <a:r>
+              <a:rPr sz="1200" b="1">
+                <a:solidFill>
+                  <a:srgbClr val="2F5D8A"/>
+                </a:solidFill>
+                <a:latin typeface="Segoe UI"/>
+              </a:rPr>
+              <a:t>TAB ✓</a:t>
+            </a:r>
+            <a:r>
+              <a:rPr sz="1200" b="1">
+                <a:solidFill>
+                  <a:srgbClr val="B5762A"/>
+                </a:solidFill>
+                <a:latin typeface="Segoe UI"/>
+              </a:rPr>
+              <a:t>   →   </a:t>
+            </a:r>
+            <a:r>
+              <a:rPr sz="1200" b="1">
+                <a:solidFill>
+                  <a:srgbClr val="2F5D8A"/>
+                </a:solidFill>
+                <a:latin typeface="Segoe UI"/>
+              </a:rPr>
+              <a:t>Parmak ✓</a:t>
+            </a:r>
+            <a:r>
+              <a:rPr sz="1200" b="1">
+                <a:solidFill>
+                  <a:srgbClr val="B5762A"/>
+                </a:solidFill>
+                <a:latin typeface="Segoe UI"/>
+              </a:rPr>
+              <a:t>   →   </a:t>
+            </a:r>
+            <a:r>
+              <a:rPr sz="1200" b="1">
+                <a:solidFill>
+                  <a:srgbClr val="2F5D8A"/>
+                </a:solidFill>
+                <a:latin typeface="Segoe UI"/>
+              </a:rPr>
+              <a:t>Görsel ✓</a:t>
             </a:r>
           </a:p>
         </p:txBody>

</xml_diff>